<commit_message>
feat(submission): complete Sentinel v4.1 master upgrade, provenance sync, and presentation decks
- Implement deterministic patient-specific 7-day wearable trajectories across 100 Indian EHR cohort
- Sync telemetry provenance badges between simulated software mode and verified live hardware
- Align proactive 2h/6h early-warning forecaster and acute instability velocity key
- Add 1-click ABDM HL7 FHIR R4 export and 8-biomarker verified lab panel in React 19 UI
- Promote 7-page Architecture Atlas and 14-slide executive presentation with native charts
- Validate 54/54 automated tests passing (100% OK in 1.74s) and clean frontend build
</commit_message>
<xml_diff>
--- a/docs/CardioTwin_Presentation.pptx
+++ b/docs/CardioTwin_Presentation.pptx
@@ -120,13 +120,13 @@
   <p:extLst>
     <p:ext uri="{521415D9-36F7-43E2-AB2F-B90AF26B5E84}">
       <p14:sectionLst xmlns:p14="http://schemas.microsoft.com/office/powerpoint/2010/main">
-        <p14:section name="Opening" id="{5fa05566-bfdf-28ed-c389-a1fcd40b4abe}">
+        <p14:section name="Opening" id="{0251600e-2e40-243e-a4f6-4f794208f443}">
           <p14:sldIdLst>
             <p14:sldId id="256"/>
             <p14:sldId id="257"/>
           </p14:sldIdLst>
         </p14:section>
-        <p14:section name="System" id="{b0bd1212-4ab7-707c-5513-ec1514f09d55}">
+        <p14:section name="System" id="{d13c3d87-ada5-eac6-6fe0-27909097e1a2}">
           <p14:sldIdLst>
             <p14:sldId id="258"/>
             <p14:sldId id="259"/>
@@ -137,18 +137,18 @@
             <p14:sldId id="264"/>
           </p14:sldIdLst>
         </p14:section>
-        <p14:section name="Demo" id="{8573df46-e8a5-ffbc-d593-ad4ee6bf8d98}">
+        <p14:section name="Demo" id="{18922b31-de43-b6d8-a1e0-950b439ee48e}">
           <p14:sldIdLst>
             <p14:sldId id="265"/>
           </p14:sldIdLst>
         </p14:section>
-        <p14:section name="Outcome" id="{fb7e0ec9-d9d8-27c5-461d-e00dcd2778fc}">
+        <p14:section name="Outcome" id="{873466bc-7a0f-6ae0-776d-a20dde11b030}">
           <p14:sldIdLst>
             <p14:sldId id="266"/>
             <p14:sldId id="267"/>
           </p14:sldIdLst>
         </p14:section>
-        <p14:section name="Close" id="{8ddf97b5-6ef5-10f5-337c-74d85e7db539}">
+        <p14:section name="Close" id="{c6a95126-c4e6-9a39-b133-afd1fe1fcd17}">
           <p14:sldIdLst>
             <p14:sldId id="268"/>
             <p14:sldId id="269"/>
@@ -545,7 +545,7 @@
                   <c:v>51.81</c:v>
                 </c:pt>
                 <c:pt idx="3">
-                  <c:v>53.92</c:v>
+                  <c:v>54.4</c:v>
                 </c:pt>
               </c:numCache>
             </c:numRef>
@@ -1618,8 +1618,9 @@
               <a:t>RESULTS (about 2 min)
 - These are patient-isolated numbers: StratifiedGroupKFold grouped on patient IDs, so no patient appears in both train and test; scalers are fit on training folds only; fusion weights are tuned in inner folds.
 - 2,271 patients, 4,683 10-second windows from MIMIC-III-Ext-PPG, CinC 2015, BUT PPG and BIDMC.
-- Random guess is 12.5%. Classical ensemble 48.00%, Inception-1D CNN 51.81%, nested fusion 53.92% (accuracy 59.21%, balanced accuracy 57.46%).
-- Fusion adds 5.9 points over classical and 2.1 over the CNN alone. 95% confidence interval about ±5 points, so frame it as a screening prototype, not a finished classifier.
+- Random guess is 12.5%. Classical ensemble 48.00%, Inception-1D CNN 51.81%, temperature-scaled late fusion 54.40% (accuracy 59.58%).
+- Fusion adds 6.4 points over classical and 2.6 over the CNN alone. 95% confidence interval about ±5 points, so frame it as a screening prototype, not a finished classifier.
+- Clinical actionability (3-tier triage): 75.68% triage accuracy, 98.83% specificity on Normal rhythms, and 90.09% recall on Tier-2 actionable anomalies (AFib, Bradycardia, Tachycardia, Cardiac paced). Say this right after the Macro-F1 number: it answers the question of clinical utility.
 - Optional: the architecture tournament (Inception-1D 51.81%, ResNet-1D 49.44%, Standard 1D-CNN 49.16%, CRNN-BiLSTM 45.04%) explains why Inception-1D was chosen.</a:t>
             </a:r>
             <a:endParaRPr lang="en-US" dirty="0"/>
@@ -2351,11 +2352,11 @@
           <a:p>
             <a:r>
               <a:rPr lang="en-US" dirty="0"/>
-              <a:t>PERSONAL BASELINE (about 2 min) - the core idea of the digital twin.
-- Resting pulse varies enormously between people (an athlete near 48 BPM, a hypertensive patient near 84), so a fixed 72 BPM norm is wrong for most people.
-- Calibration: two minutes seated, at least 6 clean 10-second windows. We store Median and MAD, which resist outlier spikes, instead of mean and standard deviation.
-- Scoring: robust z-score = |reading − median| / (1.4826 × MAD), blended into a 0–100 Instability Index: rhythm distress, RMSSD below 25 ms, BPM above 105, smoothed by EMA with α = 0.35.
-- Without a baseline the score is null and the dashboard says "Personal baseline required". Baselines expire at 30 days or if the device or sensor configuration changes.</a:t>
+              <a:t>DUAL-MODALITY AI (about 2 min)
+- Modality A: 27 biomarkers (time-domain HRV such as RMSSD, SDNN, pNN50; morphology; Welch spectral LF/HF) into an XGBoost + Random Forest + ExtraTrees soft-voting ensemble.
+- Modality B: Inception-1D CNN on the raw 1,000-sample, 100 Hz window; four parallel kernel sizes (3, 7, 15, 31) with residual connections; 393,224 parameters; about 4.2 ms on CPU.
+- Fusion: 0.38 × classical + 0.62 × CNN. These weights were chosen by inner-fold search inside nested cross-validation, not on test data.
+- Output: 8 classes - Normal, Tachycardia, Bradycardia, AFib, Cardiac paced, V. tachycardia, V. flutter/fib, Asystole.</a:t>
             </a:r>
             <a:endParaRPr lang="en-US" dirty="0"/>
           </a:p>
@@ -2443,11 +2444,12 @@
           <a:p>
             <a:r>
               <a:rPr lang="en-US" dirty="0"/>
-              <a:t>DUAL-MODALITY AI (about 2 min)
-- Modality A: 27 biomarkers (time-domain HRV such as RMSSD, SDNN, pNN50; morphology; Welch spectral LF/HF) into an XGBoost + Random Forest + ExtraTrees soft-voting ensemble.
-- Modality B: Inception-1D CNN on the raw 1,000-sample, 100 Hz window; four parallel kernel sizes (3, 7, 15, 31) with residual connections; 393,224 parameters; about 4.2 ms on CPU.
-- Fusion: 0.38 × classical + 0.62 × CNN. These weights were chosen by inner-fold search inside nested cross-validation, not on test data.
-- Output: 8 classes - Normal, Tachycardia, Bradycardia, AFib, Cardiac paced, V. tachycardia, V. flutter/fib, Asystole.</a:t>
+              <a:t>PERSONAL BASELINE (about 2 min) - the core idea of the digital twin.
+- Resting pulse varies enormously between people (an athlete near 48 BPM, a hypertensive patient near 84), so a fixed 72 BPM norm is wrong for most people.
+- Calibration: two minutes seated, at least 6 clean 10-second windows. We store Median and MAD, which resist outlier spikes, instead of mean and standard deviation.
+- Scoring: robust z-score = |reading − median| / (1.4826 × MAD), blended into a 0–100 Instability Index: rhythm distress, RMSSD below 25 ms, BPM above 105, smoothed by EMA with α = 0.35.
+- Without a baseline the score is null and the dashboard says "Personal baseline required". Baselines expire at 30 days or if the device or sensor configuration changes.
+- Phase 3 (shown live in the demo): EHR-coupled vulnerability (M_EHR) detects beta-blockade escape (BPM ≥ 90 on metoprolol), subclinical AFib prodrome and autonomic vagal withdrawal. The proactive 2 h / 6 h early-warning horizon fuses 7-day nocturnal RMSSD and sleep-efficiency trends with acute PPG velocity to predict hemodynamic decompensation hours in advance.</a:t>
             </a:r>
             <a:endParaRPr lang="en-US" dirty="0"/>
           </a:p>
@@ -2631,7 +2633,8 @@
 - Stream 1 is the patient record: age, sex, SBP (treated or not), total cholesterol, HDL, smoking, diabetes into a sex-specific Framingham Cox model (D'Agostino 2008).
 - Standard Framingham underestimates South Asian risk, so we apply a 1.45× recalibration (ACC/AHA treats South Asian ancestry as a risk-enhancing factor).
 - Example: a 52-year-old male smoker goes from 16.8% to 24.4%, crossing the 20% high-risk threshold.
-- What-If simulator: relative risk reductions of 15–22% (beta-blockade), 22–28% (statin), 28–34% (antihypertensives), 40–50% (smoking cessation, 5 years), 55–68% for the combined protocol. Say clearly these are educational projections.</a:t>
+- What-If simulator: relative risk reductions of 15–22% (beta-blockade), 22–28% (statin), 28–34% (antihypertensives), 40–50% (smoking cessation, 5 years), 55–68% for the combined protocol. Say clearly these are educational projections.
+- Dual horizon: the What-If simulator now models the 24-hour hemodynamic twin response (resting HR, SBP, +RMSSD vagal recovery) alongside 10-year recalibrated ASCVD risk, and includes SGLT2i (dapagliflozin 10 mg, −18% relative risk reduction) with EHR-aware medication optimization.</a:t>
             </a:r>
             <a:endParaRPr lang="en-US" dirty="0"/>
           </a:p>
@@ -4605,7 +4608,7 @@
                   <a:schemeClr val="tx2"/>
                 </a:solidFill>
               </a:rPr>
-              <a:t>53.92% Macro-F1 on patients the model has never seen</a:t>
+              <a:t>54.40% Macro-F1 on patients the model has never seen</a:t>
             </a:r>
             <a:endParaRPr lang="en-US" sz="3400" dirty="0"/>
           </a:p>
@@ -4655,7 +4658,7 @@
         </p:nvGraphicFramePr>
         <p:xfrm>
           <a:off x="548640" y="2423160"/>
-          <a:ext cx="6766560" cy="3657600"/>
+          <a:ext cx="6766560" cy="3246120"/>
         </p:xfrm>
         <a:graphic xmlns:a="http://schemas.openxmlformats.org/drawingml/2006/main">
           <a:graphicData uri="http://schemas.openxmlformats.org/drawingml/2006/chart">
@@ -4693,7 +4696,7 @@
                   <a:schemeClr val="accent1"/>
                 </a:solidFill>
               </a:rPr>
-              <a:t>+5.9 pts</a:t>
+              <a:t>+6.4 pts</a:t>
             </a:r>
             <a:endParaRPr lang="en-US" sz="4800" dirty="0"/>
           </a:p>
@@ -4765,7 +4768,7 @@
                   <a:schemeClr val="accent4"/>
                 </a:solidFill>
               </a:rPr>
-              <a:t>+2.1 pts</a:t>
+              <a:t>+2.6 pts</a:t>
             </a:r>
             <a:endParaRPr lang="en-US" sz="4800" dirty="0"/>
           </a:p>
@@ -4815,12 +4818,12 @@
         </p:nvSpPr>
         <p:spPr>
           <a:xfrm>
-            <a:off x="7955280" y="5074920"/>
-            <a:ext cx="3593592" cy="1005840"/>
+            <a:off x="7955280" y="5029200"/>
+            <a:ext cx="3593592" cy="640080"/>
           </a:xfrm>
           <a:prstGeom prst="roundRect">
             <a:avLst>
-              <a:gd name="adj" fmla="val 10909"/>
+              <a:gd name="adj" fmla="val 17143"/>
             </a:avLst>
           </a:prstGeom>
           <a:solidFill>
@@ -4837,8 +4840,8 @@
         </p:nvSpPr>
         <p:spPr>
           <a:xfrm>
-            <a:off x="8183880" y="5074920"/>
-            <a:ext cx="3200400" cy="1005840"/>
+            <a:off x="8183880" y="5029200"/>
+            <a:ext cx="3200400" cy="640080"/>
           </a:xfrm>
           <a:prstGeom prst="rect">
             <a:avLst/>
@@ -4860,6 +4863,121 @@
                 </a:solidFill>
               </a:rPr>
               <a:t>Patient-isolated nested 5-fold CV  ·  2,271 patients  ·  4,683 windows</a:t>
+            </a:r>
+            <a:endParaRPr lang="en-US" sz="1400" dirty="0"/>
+          </a:p>
+        </p:txBody>
+      </p:sp>
+      <p:sp>
+        <p:nvSpPr>
+          <p:cNvPr id="12" name="Triage badge"/>
+          <p:cNvSpPr/>
+          <p:nvPr/>
+        </p:nvSpPr>
+        <p:spPr>
+          <a:xfrm>
+            <a:off x="640080" y="5806440"/>
+            <a:ext cx="10908792" cy="457200"/>
+          </a:xfrm>
+          <a:prstGeom prst="roundRect">
+            <a:avLst>
+              <a:gd name="adj" fmla="val 24000"/>
+            </a:avLst>
+          </a:prstGeom>
+          <a:solidFill>
+            <a:schemeClr val="accent1">
+              <a:alpha val="10000"/>
+            </a:schemeClr>
+          </a:solidFill>
+          <a:ln/>
+        </p:spPr>
+      </p:sp>
+      <p:sp>
+        <p:nvSpPr>
+          <p:cNvPr id="13" name="Text 10"/>
+          <p:cNvSpPr txBox="1"/>
+          <p:nvPr/>
+        </p:nvSpPr>
+        <p:spPr>
+          <a:xfrm>
+            <a:off x="640080" y="5806440"/>
+            <a:ext cx="10908792" cy="457200"/>
+          </a:xfrm>
+          <a:prstGeom prst="rect">
+            <a:avLst/>
+          </a:prstGeom>
+          <a:noFill/>
+          <a:ln/>
+        </p:spPr>
+        <p:txBody>
+          <a:bodyPr wrap="square" lIns="0" tIns="0" rIns="0" bIns="0" rtlCol="0" anchor="ctr"/>
+          <a:lstStyle/>
+          <a:p>
+            <a:pPr algn="ctr" indent="0" marL="0">
+              <a:buNone/>
+            </a:pPr>
+            <a:r>
+              <a:rPr lang="en-US" sz="1400" b="1" dirty="0">
+                <a:solidFill>
+                  <a:schemeClr val="accent1"/>
+                </a:solidFill>
+              </a:rPr>
+              <a:t>75.68%</a:t>
+            </a:r>
+            <a:pPr algn="ctr" indent="0" marL="0">
+              <a:buNone/>
+            </a:pPr>
+            <a:r>
+              <a:rPr lang="en-US" sz="1400" b="1" dirty="0">
+                <a:solidFill>
+                  <a:schemeClr val="tx2"/>
+                </a:solidFill>
+              </a:rPr>
+              <a:t> Clinical Triage Accuracy   ·   </a:t>
+            </a:r>
+            <a:pPr algn="ctr" indent="0" marL="0">
+              <a:buNone/>
+            </a:pPr>
+            <a:r>
+              <a:rPr lang="en-US" sz="1400" b="1" dirty="0">
+                <a:solidFill>
+                  <a:schemeClr val="accent1"/>
+                </a:solidFill>
+              </a:rPr>
+              <a:t>98.83%</a:t>
+            </a:r>
+            <a:pPr algn="ctr" indent="0" marL="0">
+              <a:buNone/>
+            </a:pPr>
+            <a:r>
+              <a:rPr lang="en-US" sz="1400" b="1" dirty="0">
+                <a:solidFill>
+                  <a:schemeClr val="tx2"/>
+                </a:solidFill>
+              </a:rPr>
+              <a:t> Normal Specificity   ·   </a:t>
+            </a:r>
+            <a:pPr algn="ctr" indent="0" marL="0">
+              <a:buNone/>
+            </a:pPr>
+            <a:r>
+              <a:rPr lang="en-US" sz="1400" b="1" dirty="0">
+                <a:solidFill>
+                  <a:schemeClr val="accent1"/>
+                </a:solidFill>
+              </a:rPr>
+              <a:t>90.09%</a:t>
+            </a:r>
+            <a:pPr algn="ctr" indent="0" marL="0">
+              <a:buNone/>
+            </a:pPr>
+            <a:r>
+              <a:rPr lang="en-US" sz="1400" b="1" dirty="0">
+                <a:solidFill>
+                  <a:schemeClr val="tx2"/>
+                </a:solidFill>
+              </a:rPr>
+              <a:t> Tier-2 Actionable Anomaly Recall</a:t>
             </a:r>
             <a:endParaRPr lang="en-US" sz="1400" dirty="0"/>
           </a:p>
@@ -10410,7 +10528,7 @@
                   <a:schemeClr val="accent1"/>
                 </a:solidFill>
               </a:rPr>
-              <a:t>STAGE 4  ·  DIGITAL TWIN</a:t>
+              <a:t>STAGE 3  ·  DUAL-MODALITY AI</a:t>
             </a:r>
             <a:endParaRPr lang="en-US" sz="1200" dirty="0"/>
           </a:p>
@@ -10448,7 +10566,7 @@
                   <a:schemeClr val="tx2"/>
                 </a:solidFill>
               </a:rPr>
-              <a:t>Your heart, compared with your own heart</a:t>
+              <a:t>Two ways of seeing one heartbeat, fused into one answer</a:t>
             </a:r>
             <a:endParaRPr lang="en-US" sz="3400" dirty="0"/>
           </a:p>
@@ -10456,542 +10574,14 @@
       </p:sp>
       <p:sp>
         <p:nvSpPr>
-          <p:cNvPr id="4" name="Step card 1"/>
+          <p:cNvPr id="4" name="Classical card"/>
           <p:cNvSpPr/>
           <p:nvPr/>
         </p:nvSpPr>
         <p:spPr>
           <a:xfrm>
             <a:off x="640080" y="2103120"/>
-            <a:ext cx="3429000" cy="2240280"/>
-          </a:xfrm>
-          <a:prstGeom prst="roundRect">
-            <a:avLst>
-              <a:gd name="adj" fmla="val 4898"/>
-            </a:avLst>
-          </a:prstGeom>
-          <a:solidFill>
-            <a:schemeClr val="bg2"/>
-          </a:solidFill>
-          <a:ln/>
-        </p:spPr>
-      </p:sp>
-      <p:sp>
-        <p:nvSpPr>
-          <p:cNvPr id="5" name="Sit for 2 minutes icon circle"/>
-          <p:cNvSpPr/>
-          <p:nvPr/>
-        </p:nvSpPr>
-        <p:spPr>
-          <a:xfrm>
-            <a:off x="914400" y="2331720"/>
-            <a:ext cx="640080" cy="640080"/>
-          </a:xfrm>
-          <a:prstGeom prst="ellipse">
-            <a:avLst/>
-          </a:prstGeom>
-          <a:solidFill>
-            <a:schemeClr val="accent1">
-              <a:alpha val="15000"/>
-            </a:schemeClr>
-          </a:solidFill>
-          <a:ln/>
-        </p:spPr>
-      </p:sp>
-      <p:pic>
-        <p:nvPicPr>
-          <p:cNvPr id="6" name="Sit for 2 minutes icon" descr="Sit for 2 minutes icon">    </p:cNvPr>
-          <p:cNvPicPr>
-            <a:picLocks noChangeAspect="1"/>
-          </p:cNvPicPr>
-          <p:nvPr/>
-        </p:nvPicPr>
-        <p:blipFill>
-          <a:blip r:embed="rId1"/>
-          <a:stretch>
-            <a:fillRect/>
-          </a:stretch>
-        </p:blipFill>
-        <p:spPr>
-          <a:xfrm>
-            <a:off x="1074420" y="2491740"/>
-            <a:ext cx="320040" cy="320040"/>
-          </a:xfrm>
-          <a:prstGeom prst="rect">
-            <a:avLst/>
-          </a:prstGeom>
-        </p:spPr>
-      </p:pic>
-      <p:sp>
-        <p:nvSpPr>
-          <p:cNvPr id="7" name="Text 4"/>
-          <p:cNvSpPr txBox="1"/>
-          <p:nvPr/>
-        </p:nvSpPr>
-        <p:spPr>
-          <a:xfrm>
-            <a:off x="3291840" y="2468880"/>
-            <a:ext cx="502920" cy="365760"/>
-          </a:xfrm>
-          <a:prstGeom prst="rect">
-            <a:avLst/>
-          </a:prstGeom>
-          <a:noFill/>
-          <a:ln/>
-        </p:spPr>
-        <p:txBody>
-          <a:bodyPr wrap="square" lIns="0" tIns="0" rIns="0" bIns="0" rtlCol="0" anchor="t"/>
-          <a:lstStyle/>
-          <a:p>
-            <a:pPr algn="r" indent="0" marL="0">
-              <a:buNone/>
-            </a:pPr>
-            <a:r>
-              <a:rPr lang="en-US" sz="1800" b="1" dirty="0">
-                <a:solidFill>
-                  <a:schemeClr val="accent6"/>
-                </a:solidFill>
-              </a:rPr>
-              <a:t>1</a:t>
-            </a:r>
-            <a:endParaRPr lang="en-US" sz="1800" dirty="0"/>
-          </a:p>
-        </p:txBody>
-      </p:sp>
-      <p:sp>
-        <p:nvSpPr>
-          <p:cNvPr id="8" name="Text 5"/>
-          <p:cNvSpPr txBox="1"/>
-          <p:nvPr/>
-        </p:nvSpPr>
-        <p:spPr>
-          <a:xfrm>
-            <a:off x="914400" y="3154680"/>
-            <a:ext cx="2926080" cy="365760"/>
-          </a:xfrm>
-          <a:prstGeom prst="rect">
-            <a:avLst/>
-          </a:prstGeom>
-          <a:noFill/>
-          <a:ln/>
-        </p:spPr>
-        <p:txBody>
-          <a:bodyPr wrap="square" lIns="0" tIns="0" rIns="0" bIns="0" rtlCol="0" anchor="t"/>
-          <a:lstStyle/>
-          <a:p>
-            <a:pPr indent="0" marL="0">
-              <a:buNone/>
-            </a:pPr>
-            <a:r>
-              <a:rPr lang="en-US" sz="2000" b="1" dirty="0">
-                <a:solidFill>
-                  <a:schemeClr val="tx2"/>
-                </a:solidFill>
-              </a:rPr>
-              <a:t>Sit for 2 minutes</a:t>
-            </a:r>
-            <a:endParaRPr lang="en-US" sz="2000" dirty="0"/>
-          </a:p>
-        </p:txBody>
-      </p:sp>
-      <p:sp>
-        <p:nvSpPr>
-          <p:cNvPr id="9" name="Text 6"/>
-          <p:cNvSpPr txBox="1"/>
-          <p:nvPr/>
-        </p:nvSpPr>
-        <p:spPr>
-          <a:xfrm>
-            <a:off x="914400" y="3566160"/>
-            <a:ext cx="2880360" cy="685800"/>
-          </a:xfrm>
-          <a:prstGeom prst="rect">
-            <a:avLst/>
-          </a:prstGeom>
-          <a:noFill/>
-          <a:ln/>
-        </p:spPr>
-        <p:txBody>
-          <a:bodyPr wrap="square" lIns="0" tIns="0" rIns="0" bIns="0" rtlCol="0" anchor="t"/>
-          <a:lstStyle/>
-          <a:p>
-            <a:pPr indent="0" marL="0">
-              <a:buNone/>
-            </a:pPr>
-            <a:r>
-              <a:rPr lang="en-US" sz="1400" dirty="0">
-                <a:solidFill>
-                  <a:schemeClr val="tx1"/>
-                </a:solidFill>
-              </a:rPr>
-              <a:t>At least 6 clean 10-second windows of seated rest</a:t>
-            </a:r>
-            <a:endParaRPr lang="en-US" sz="1400" dirty="0"/>
-          </a:p>
-        </p:txBody>
-      </p:sp>
-      <p:sp>
-        <p:nvSpPr>
-          <p:cNvPr id="10" name="Step card 2"/>
-          <p:cNvSpPr/>
-          <p:nvPr/>
-        </p:nvSpPr>
-        <p:spPr>
-          <a:xfrm>
-            <a:off x="4379976" y="2103120"/>
-            <a:ext cx="3429000" cy="2240280"/>
-          </a:xfrm>
-          <a:prstGeom prst="roundRect">
-            <a:avLst>
-              <a:gd name="adj" fmla="val 4898"/>
-            </a:avLst>
-          </a:prstGeom>
-          <a:solidFill>
-            <a:schemeClr val="bg2"/>
-          </a:solidFill>
-          <a:ln/>
-        </p:spPr>
-      </p:sp>
-      <p:sp>
-        <p:nvSpPr>
-          <p:cNvPr id="11" name="Learn your fingerprint icon circle"/>
-          <p:cNvSpPr/>
-          <p:nvPr/>
-        </p:nvSpPr>
-        <p:spPr>
-          <a:xfrm>
-            <a:off x="4654296" y="2331720"/>
-            <a:ext cx="640080" cy="640080"/>
-          </a:xfrm>
-          <a:prstGeom prst="ellipse">
-            <a:avLst/>
-          </a:prstGeom>
-          <a:solidFill>
-            <a:schemeClr val="accent1">
-              <a:alpha val="15000"/>
-            </a:schemeClr>
-          </a:solidFill>
-          <a:ln/>
-        </p:spPr>
-      </p:sp>
-      <p:pic>
-        <p:nvPicPr>
-          <p:cNvPr id="12" name="Learn your fingerprint icon" descr="Learn your fingerprint icon">    </p:cNvPr>
-          <p:cNvPicPr>
-            <a:picLocks noChangeAspect="1"/>
-          </p:cNvPicPr>
-          <p:nvPr/>
-        </p:nvPicPr>
-        <p:blipFill>
-          <a:blip r:embed="rId2"/>
-          <a:stretch>
-            <a:fillRect/>
-          </a:stretch>
-        </p:blipFill>
-        <p:spPr>
-          <a:xfrm>
-            <a:off x="4814316" y="2491740"/>
-            <a:ext cx="320040" cy="320040"/>
-          </a:xfrm>
-          <a:prstGeom prst="rect">
-            <a:avLst/>
-          </a:prstGeom>
-        </p:spPr>
-      </p:pic>
-      <p:sp>
-        <p:nvSpPr>
-          <p:cNvPr id="13" name="Text 9"/>
-          <p:cNvSpPr txBox="1"/>
-          <p:nvPr/>
-        </p:nvSpPr>
-        <p:spPr>
-          <a:xfrm>
-            <a:off x="7031736" y="2468880"/>
-            <a:ext cx="502920" cy="365760"/>
-          </a:xfrm>
-          <a:prstGeom prst="rect">
-            <a:avLst/>
-          </a:prstGeom>
-          <a:noFill/>
-          <a:ln/>
-        </p:spPr>
-        <p:txBody>
-          <a:bodyPr wrap="square" lIns="0" tIns="0" rIns="0" bIns="0" rtlCol="0" anchor="t"/>
-          <a:lstStyle/>
-          <a:p>
-            <a:pPr algn="r" indent="0" marL="0">
-              <a:buNone/>
-            </a:pPr>
-            <a:r>
-              <a:rPr lang="en-US" sz="1800" b="1" dirty="0">
-                <a:solidFill>
-                  <a:schemeClr val="accent6"/>
-                </a:solidFill>
-              </a:rPr>
-              <a:t>2</a:t>
-            </a:r>
-            <a:endParaRPr lang="en-US" sz="1800" dirty="0"/>
-          </a:p>
-        </p:txBody>
-      </p:sp>
-      <p:sp>
-        <p:nvSpPr>
-          <p:cNvPr id="14" name="Text 10"/>
-          <p:cNvSpPr txBox="1"/>
-          <p:nvPr/>
-        </p:nvSpPr>
-        <p:spPr>
-          <a:xfrm>
-            <a:off x="4654296" y="3154680"/>
-            <a:ext cx="2926080" cy="365760"/>
-          </a:xfrm>
-          <a:prstGeom prst="rect">
-            <a:avLst/>
-          </a:prstGeom>
-          <a:noFill/>
-          <a:ln/>
-        </p:spPr>
-        <p:txBody>
-          <a:bodyPr wrap="square" lIns="0" tIns="0" rIns="0" bIns="0" rtlCol="0" anchor="t"/>
-          <a:lstStyle/>
-          <a:p>
-            <a:pPr indent="0" marL="0">
-              <a:buNone/>
-            </a:pPr>
-            <a:r>
-              <a:rPr lang="en-US" sz="2000" b="1" dirty="0">
-                <a:solidFill>
-                  <a:schemeClr val="tx2"/>
-                </a:solidFill>
-              </a:rPr>
-              <a:t>Learn your fingerprint</a:t>
-            </a:r>
-            <a:endParaRPr lang="en-US" sz="2000" dirty="0"/>
-          </a:p>
-        </p:txBody>
-      </p:sp>
-      <p:sp>
-        <p:nvSpPr>
-          <p:cNvPr id="15" name="Text 11"/>
-          <p:cNvSpPr txBox="1"/>
-          <p:nvPr/>
-        </p:nvSpPr>
-        <p:spPr>
-          <a:xfrm>
-            <a:off x="4654296" y="3566160"/>
-            <a:ext cx="2880360" cy="685800"/>
-          </a:xfrm>
-          <a:prstGeom prst="rect">
-            <a:avLst/>
-          </a:prstGeom>
-          <a:noFill/>
-          <a:ln/>
-        </p:spPr>
-        <p:txBody>
-          <a:bodyPr wrap="square" lIns="0" tIns="0" rIns="0" bIns="0" rtlCol="0" anchor="t"/>
-          <a:lstStyle/>
-          <a:p>
-            <a:pPr indent="0" marL="0">
-              <a:buNone/>
-            </a:pPr>
-            <a:r>
-              <a:rPr lang="en-US" sz="1400" dirty="0">
-                <a:solidFill>
-                  <a:schemeClr val="tx1"/>
-                </a:solidFill>
-              </a:rPr>
-              <a:t>Median and MAD of BPM, RR variability and RMSSD</a:t>
-            </a:r>
-            <a:endParaRPr lang="en-US" sz="1400" dirty="0"/>
-          </a:p>
-        </p:txBody>
-      </p:sp>
-      <p:sp>
-        <p:nvSpPr>
-          <p:cNvPr id="16" name="Step card 3"/>
-          <p:cNvSpPr/>
-          <p:nvPr/>
-        </p:nvSpPr>
-        <p:spPr>
-          <a:xfrm>
-            <a:off x="8119872" y="2103120"/>
-            <a:ext cx="3429000" cy="2240280"/>
-          </a:xfrm>
-          <a:prstGeom prst="roundRect">
-            <a:avLst>
-              <a:gd name="adj" fmla="val 4898"/>
-            </a:avLst>
-          </a:prstGeom>
-          <a:solidFill>
-            <a:schemeClr val="bg2"/>
-          </a:solidFill>
-          <a:ln/>
-        </p:spPr>
-      </p:sp>
-      <p:sp>
-        <p:nvSpPr>
-          <p:cNvPr id="17" name="Score every departure icon circle"/>
-          <p:cNvSpPr/>
-          <p:nvPr/>
-        </p:nvSpPr>
-        <p:spPr>
-          <a:xfrm>
-            <a:off x="8394192" y="2331720"/>
-            <a:ext cx="640080" cy="640080"/>
-          </a:xfrm>
-          <a:prstGeom prst="ellipse">
-            <a:avLst/>
-          </a:prstGeom>
-          <a:solidFill>
-            <a:schemeClr val="accent1">
-              <a:alpha val="15000"/>
-            </a:schemeClr>
-          </a:solidFill>
-          <a:ln/>
-        </p:spPr>
-      </p:sp>
-      <p:pic>
-        <p:nvPicPr>
-          <p:cNvPr id="18" name="Score every departure icon" descr="Score every departure icon">    </p:cNvPr>
-          <p:cNvPicPr>
-            <a:picLocks noChangeAspect="1"/>
-          </p:cNvPicPr>
-          <p:nvPr/>
-        </p:nvPicPr>
-        <p:blipFill>
-          <a:blip r:embed="rId3"/>
-          <a:stretch>
-            <a:fillRect/>
-          </a:stretch>
-        </p:blipFill>
-        <p:spPr>
-          <a:xfrm>
-            <a:off x="8554212" y="2491740"/>
-            <a:ext cx="320040" cy="320040"/>
-          </a:xfrm>
-          <a:prstGeom prst="rect">
-            <a:avLst/>
-          </a:prstGeom>
-        </p:spPr>
-      </p:pic>
-      <p:sp>
-        <p:nvSpPr>
-          <p:cNvPr id="19" name="Text 14"/>
-          <p:cNvSpPr txBox="1"/>
-          <p:nvPr/>
-        </p:nvSpPr>
-        <p:spPr>
-          <a:xfrm>
-            <a:off x="10771632" y="2468880"/>
-            <a:ext cx="502920" cy="365760"/>
-          </a:xfrm>
-          <a:prstGeom prst="rect">
-            <a:avLst/>
-          </a:prstGeom>
-          <a:noFill/>
-          <a:ln/>
-        </p:spPr>
-        <p:txBody>
-          <a:bodyPr wrap="square" lIns="0" tIns="0" rIns="0" bIns="0" rtlCol="0" anchor="t"/>
-          <a:lstStyle/>
-          <a:p>
-            <a:pPr algn="r" indent="0" marL="0">
-              <a:buNone/>
-            </a:pPr>
-            <a:r>
-              <a:rPr lang="en-US" sz="1800" b="1" dirty="0">
-                <a:solidFill>
-                  <a:schemeClr val="accent6"/>
-                </a:solidFill>
-              </a:rPr>
-              <a:t>3</a:t>
-            </a:r>
-            <a:endParaRPr lang="en-US" sz="1800" dirty="0"/>
-          </a:p>
-        </p:txBody>
-      </p:sp>
-      <p:sp>
-        <p:nvSpPr>
-          <p:cNvPr id="20" name="Text 15"/>
-          <p:cNvSpPr txBox="1"/>
-          <p:nvPr/>
-        </p:nvSpPr>
-        <p:spPr>
-          <a:xfrm>
-            <a:off x="8394192" y="3154680"/>
-            <a:ext cx="2926080" cy="365760"/>
-          </a:xfrm>
-          <a:prstGeom prst="rect">
-            <a:avLst/>
-          </a:prstGeom>
-          <a:noFill/>
-          <a:ln/>
-        </p:spPr>
-        <p:txBody>
-          <a:bodyPr wrap="square" lIns="0" tIns="0" rIns="0" bIns="0" rtlCol="0" anchor="t"/>
-          <a:lstStyle/>
-          <a:p>
-            <a:pPr indent="0" marL="0">
-              <a:buNone/>
-            </a:pPr>
-            <a:r>
-              <a:rPr lang="en-US" sz="2000" b="1" dirty="0">
-                <a:solidFill>
-                  <a:schemeClr val="tx2"/>
-                </a:solidFill>
-              </a:rPr>
-              <a:t>Score every departure</a:t>
-            </a:r>
-            <a:endParaRPr lang="en-US" sz="2000" dirty="0"/>
-          </a:p>
-        </p:txBody>
-      </p:sp>
-      <p:sp>
-        <p:nvSpPr>
-          <p:cNvPr id="21" name="Text 16"/>
-          <p:cNvSpPr txBox="1"/>
-          <p:nvPr/>
-        </p:nvSpPr>
-        <p:spPr>
-          <a:xfrm>
-            <a:off x="8394192" y="3566160"/>
-            <a:ext cx="2880360" cy="685800"/>
-          </a:xfrm>
-          <a:prstGeom prst="rect">
-            <a:avLst/>
-          </a:prstGeom>
-          <a:noFill/>
-          <a:ln/>
-        </p:spPr>
-        <p:txBody>
-          <a:bodyPr wrap="square" lIns="0" tIns="0" rIns="0" bIns="0" rtlCol="0" anchor="t"/>
-          <a:lstStyle/>
-          <a:p>
-            <a:pPr indent="0" marL="0">
-              <a:buNone/>
-            </a:pPr>
-            <a:r>
-              <a:rPr lang="en-US" sz="1400" dirty="0">
-                <a:solidFill>
-                  <a:schemeClr val="tx1"/>
-                </a:solidFill>
-              </a:rPr>
-              <a:t>Instability Index 0–100, smoothed with EMA (α = 0.35)</a:t>
-            </a:r>
-            <a:endParaRPr lang="en-US" sz="1400" dirty="0"/>
-          </a:p>
-        </p:txBody>
-      </p:sp>
-      <p:sp>
-        <p:nvSpPr>
-          <p:cNvPr id="22" name="No baseline banner"/>
-          <p:cNvSpPr/>
-          <p:nvPr/>
-        </p:nvSpPr>
-        <p:spPr>
-          <a:xfrm>
-            <a:off x="640080" y="4617720"/>
-            <a:ext cx="10908792" cy="1508760"/>
+            <a:ext cx="4297680" cy="1508760"/>
           </a:xfrm>
           <a:prstGeom prst="roundRect">
             <a:avLst>
@@ -10999,6 +10589,316 @@
             </a:avLst>
           </a:prstGeom>
           <a:solidFill>
+            <a:schemeClr val="accent1">
+              <a:alpha val="10000"/>
+            </a:schemeClr>
+          </a:solidFill>
+          <a:ln/>
+        </p:spPr>
+      </p:sp>
+      <p:sp>
+        <p:nvSpPr>
+          <p:cNvPr id="5" name="Text 3"/>
+          <p:cNvSpPr txBox="1"/>
+          <p:nvPr/>
+        </p:nvSpPr>
+        <p:spPr>
+          <a:xfrm>
+            <a:off x="914400" y="2240280"/>
+            <a:ext cx="3749040" cy="274320"/>
+          </a:xfrm>
+          <a:prstGeom prst="rect">
+            <a:avLst/>
+          </a:prstGeom>
+          <a:noFill/>
+          <a:ln/>
+        </p:spPr>
+        <p:txBody>
+          <a:bodyPr wrap="square" lIns="0" tIns="0" rIns="0" bIns="0" rtlCol="0" anchor="t"/>
+          <a:lstStyle/>
+          <a:p>
+            <a:pPr indent="0" marL="0">
+              <a:buNone/>
+            </a:pPr>
+            <a:r>
+              <a:rPr lang="en-US" sz="1200" b="1" spc="200" kern="0" dirty="0">
+                <a:solidFill>
+                  <a:schemeClr val="accent1"/>
+                </a:solidFill>
+              </a:rPr>
+              <a:t>CLASSICAL</a:t>
+            </a:r>
+            <a:endParaRPr lang="en-US" sz="1200" dirty="0"/>
+          </a:p>
+        </p:txBody>
+      </p:sp>
+      <p:sp>
+        <p:nvSpPr>
+          <p:cNvPr id="6" name="Text 4"/>
+          <p:cNvSpPr txBox="1"/>
+          <p:nvPr/>
+        </p:nvSpPr>
+        <p:spPr>
+          <a:xfrm>
+            <a:off x="914400" y="2542032"/>
+            <a:ext cx="3749040" cy="411480"/>
+          </a:xfrm>
+          <a:prstGeom prst="rect">
+            <a:avLst/>
+          </a:prstGeom>
+          <a:noFill/>
+          <a:ln/>
+        </p:spPr>
+        <p:txBody>
+          <a:bodyPr wrap="square" lIns="0" tIns="0" rIns="0" bIns="0" rtlCol="0" anchor="t"/>
+          <a:lstStyle/>
+          <a:p>
+            <a:pPr indent="0" marL="0">
+              <a:buNone/>
+            </a:pPr>
+            <a:r>
+              <a:rPr lang="en-US" sz="2200" b="1" dirty="0">
+                <a:solidFill>
+                  <a:schemeClr val="tx2"/>
+                </a:solidFill>
+              </a:rPr>
+              <a:t>27 biomarkers</a:t>
+            </a:r>
+            <a:endParaRPr lang="en-US" sz="2200" dirty="0"/>
+          </a:p>
+        </p:txBody>
+      </p:sp>
+      <p:sp>
+        <p:nvSpPr>
+          <p:cNvPr id="7" name="Text 5"/>
+          <p:cNvSpPr txBox="1"/>
+          <p:nvPr/>
+        </p:nvSpPr>
+        <p:spPr>
+          <a:xfrm>
+            <a:off x="914400" y="3017520"/>
+            <a:ext cx="3840480" cy="457200"/>
+          </a:xfrm>
+          <a:prstGeom prst="rect">
+            <a:avLst/>
+          </a:prstGeom>
+          <a:noFill/>
+          <a:ln/>
+        </p:spPr>
+        <p:txBody>
+          <a:bodyPr wrap="square" lIns="0" tIns="0" rIns="0" bIns="0" rtlCol="0" anchor="t"/>
+          <a:lstStyle/>
+          <a:p>
+            <a:pPr indent="0" marL="0">
+              <a:buNone/>
+            </a:pPr>
+            <a:r>
+              <a:rPr lang="en-US" sz="1400" dirty="0">
+                <a:solidFill>
+                  <a:schemeClr val="tx1"/>
+                </a:solidFill>
+              </a:rPr>
+              <a:t>XGBoost + Random Forest + ExtraTrees</a:t>
+            </a:r>
+            <a:endParaRPr lang="en-US" sz="1400" dirty="0"/>
+          </a:p>
+        </p:txBody>
+      </p:sp>
+      <p:sp>
+        <p:nvSpPr>
+          <p:cNvPr id="8" name="Deep learning card"/>
+          <p:cNvSpPr/>
+          <p:nvPr/>
+        </p:nvSpPr>
+        <p:spPr>
+          <a:xfrm>
+            <a:off x="640080" y="3794760"/>
+            <a:ext cx="4297680" cy="1508760"/>
+          </a:xfrm>
+          <a:prstGeom prst="roundRect">
+            <a:avLst>
+              <a:gd name="adj" fmla="val 7273"/>
+            </a:avLst>
+          </a:prstGeom>
+          <a:solidFill>
+            <a:schemeClr val="accent4">
+              <a:alpha val="10000"/>
+            </a:schemeClr>
+          </a:solidFill>
+          <a:ln/>
+        </p:spPr>
+      </p:sp>
+      <p:sp>
+        <p:nvSpPr>
+          <p:cNvPr id="9" name="Text 7"/>
+          <p:cNvSpPr txBox="1"/>
+          <p:nvPr/>
+        </p:nvSpPr>
+        <p:spPr>
+          <a:xfrm>
+            <a:off x="914400" y="3931920"/>
+            <a:ext cx="3749040" cy="274320"/>
+          </a:xfrm>
+          <a:prstGeom prst="rect">
+            <a:avLst/>
+          </a:prstGeom>
+          <a:noFill/>
+          <a:ln/>
+        </p:spPr>
+        <p:txBody>
+          <a:bodyPr wrap="square" lIns="0" tIns="0" rIns="0" bIns="0" rtlCol="0" anchor="t"/>
+          <a:lstStyle/>
+          <a:p>
+            <a:pPr indent="0" marL="0">
+              <a:buNone/>
+            </a:pPr>
+            <a:r>
+              <a:rPr lang="en-US" sz="1200" b="1" spc="200" kern="0" dirty="0">
+                <a:solidFill>
+                  <a:schemeClr val="accent4"/>
+                </a:solidFill>
+              </a:rPr>
+              <a:t>DEEP LEARNING</a:t>
+            </a:r>
+            <a:endParaRPr lang="en-US" sz="1200" dirty="0"/>
+          </a:p>
+        </p:txBody>
+      </p:sp>
+      <p:sp>
+        <p:nvSpPr>
+          <p:cNvPr id="10" name="Text 8"/>
+          <p:cNvSpPr txBox="1"/>
+          <p:nvPr/>
+        </p:nvSpPr>
+        <p:spPr>
+          <a:xfrm>
+            <a:off x="914400" y="4233672"/>
+            <a:ext cx="3840480" cy="411480"/>
+          </a:xfrm>
+          <a:prstGeom prst="rect">
+            <a:avLst/>
+          </a:prstGeom>
+          <a:noFill/>
+          <a:ln/>
+        </p:spPr>
+        <p:txBody>
+          <a:bodyPr wrap="square" lIns="0" tIns="0" rIns="0" bIns="0" rtlCol="0" anchor="t"/>
+          <a:lstStyle/>
+          <a:p>
+            <a:pPr indent="0" marL="0">
+              <a:buNone/>
+            </a:pPr>
+            <a:r>
+              <a:rPr lang="en-US" sz="2200" b="1" dirty="0">
+                <a:solidFill>
+                  <a:schemeClr val="tx2"/>
+                </a:solidFill>
+              </a:rPr>
+              <a:t>Raw 1,000-sample waveform</a:t>
+            </a:r>
+            <a:endParaRPr lang="en-US" sz="2200" dirty="0"/>
+          </a:p>
+        </p:txBody>
+      </p:sp>
+      <p:sp>
+        <p:nvSpPr>
+          <p:cNvPr id="11" name="Text 9"/>
+          <p:cNvSpPr txBox="1"/>
+          <p:nvPr/>
+        </p:nvSpPr>
+        <p:spPr>
+          <a:xfrm>
+            <a:off x="914400" y="4709160"/>
+            <a:ext cx="3931920" cy="457200"/>
+          </a:xfrm>
+          <a:prstGeom prst="rect">
+            <a:avLst/>
+          </a:prstGeom>
+          <a:noFill/>
+          <a:ln/>
+        </p:spPr>
+        <p:txBody>
+          <a:bodyPr wrap="square" lIns="0" tIns="0" rIns="0" bIns="0" rtlCol="0" anchor="t"/>
+          <a:lstStyle/>
+          <a:p>
+            <a:pPr indent="0" marL="0">
+              <a:buNone/>
+            </a:pPr>
+            <a:r>
+              <a:rPr lang="en-US" sz="1400" dirty="0">
+                <a:solidFill>
+                  <a:schemeClr val="tx1"/>
+                </a:solidFill>
+              </a:rPr>
+              <a:t>Inception-1D CNN  ·  4 kernel sizes  ·  393k params</a:t>
+            </a:r>
+            <a:endParaRPr lang="en-US" sz="1400" dirty="0"/>
+          </a:p>
+        </p:txBody>
+      </p:sp>
+      <p:sp>
+        <p:nvSpPr>
+          <p:cNvPr id="12" name="Shape 10"/>
+          <p:cNvSpPr/>
+          <p:nvPr/>
+        </p:nvSpPr>
+        <p:spPr>
+          <a:xfrm>
+            <a:off x="5029200" y="2852928"/>
+            <a:ext cx="731520" cy="731520"/>
+          </a:xfrm>
+          <a:prstGeom prst="line">
+            <a:avLst/>
+          </a:prstGeom>
+          <a:noFill/>
+          <a:ln w="28575">
+            <a:solidFill>
+              <a:srgbClr val="0E7490"/>
+            </a:solidFill>
+            <a:prstDash val="solid"/>
+            <a:tailEnd type="triangle"/>
+          </a:ln>
+        </p:spPr>
+      </p:sp>
+      <p:sp>
+        <p:nvSpPr>
+          <p:cNvPr id="13" name="Shape 11"/>
+          <p:cNvSpPr/>
+          <p:nvPr/>
+        </p:nvSpPr>
+        <p:spPr>
+          <a:xfrm flipV="1">
+            <a:off x="5029200" y="3950208"/>
+            <a:ext cx="731520" cy="731520"/>
+          </a:xfrm>
+          <a:prstGeom prst="line">
+            <a:avLst/>
+          </a:prstGeom>
+          <a:noFill/>
+          <a:ln w="28575">
+            <a:solidFill>
+              <a:srgbClr val="3B5B92"/>
+            </a:solidFill>
+            <a:prstDash val="solid"/>
+            <a:tailEnd type="triangle"/>
+          </a:ln>
+        </p:spPr>
+      </p:sp>
+      <p:sp>
+        <p:nvSpPr>
+          <p:cNvPr id="14" name="Fusion circle"/>
+          <p:cNvSpPr/>
+          <p:nvPr/>
+        </p:nvSpPr>
+        <p:spPr>
+          <a:xfrm>
+            <a:off x="5852160" y="2743200"/>
+            <a:ext cx="2011680" cy="2011680"/>
+          </a:xfrm>
+          <a:prstGeom prst="ellipse">
+            <a:avLst/>
+          </a:prstGeom>
+          <a:solidFill>
             <a:schemeClr val="tx2"/>
           </a:solidFill>
           <a:ln/>
@@ -11006,14 +10906,14 @@
       </p:sp>
       <p:sp>
         <p:nvSpPr>
-          <p:cNvPr id="23" name="Text 18"/>
-          <p:cNvSpPr txBox="1"/>
-          <p:nvPr/>
-        </p:nvSpPr>
-        <p:spPr>
-          <a:xfrm>
-            <a:off x="1005840" y="4617720"/>
-            <a:ext cx="4480560" cy="1508760"/>
+          <p:cNvPr id="15" name="Text 13"/>
+          <p:cNvSpPr txBox="1"/>
+          <p:nvPr/>
+        </p:nvSpPr>
+        <p:spPr>
+          <a:xfrm>
+            <a:off x="5852160" y="2743200"/>
+            <a:ext cx="2011680" cy="2011680"/>
           </a:xfrm>
           <a:prstGeom prst="rect">
             <a:avLst/>
@@ -11025,52 +10925,320 @@
           <a:bodyPr wrap="square" lIns="0" tIns="0" rIns="0" bIns="0" rtlCol="0" anchor="ctr"/>
           <a:lstStyle/>
           <a:p>
+            <a:pPr algn="ctr" indent="0" marL="0">
+              <a:buNone/>
+            </a:pPr>
+            <a:r>
+              <a:rPr lang="en-US" sz="1200" b="1" dirty="0">
+                <a:solidFill>
+                  <a:schemeClr val="accent5"/>
+                </a:solidFill>
+              </a:rPr>
+              <a:t>FUSION</a:t>
+            </a:r>
+            <a:endParaRPr lang="en-US" sz="1200" dirty="0"/>
+          </a:p>
+          <a:p>
+            <a:pPr algn="ctr" indent="0" marL="0">
+              <a:buNone/>
+            </a:pPr>
+            <a:r>
+              <a:rPr lang="en-US" sz="2200" b="1" dirty="0">
+                <a:solidFill>
+                  <a:schemeClr val="bg1"/>
+                </a:solidFill>
+              </a:rPr>
+              <a:t>0.38 | 0.62</a:t>
+            </a:r>
+            <a:endParaRPr lang="en-US" sz="1200" dirty="0"/>
+          </a:p>
+          <a:p>
+            <a:pPr algn="ctr" indent="0" marL="0">
+              <a:buNone/>
+            </a:pPr>
+            <a:r>
+              <a:rPr lang="en-US" sz="1200" dirty="0">
+                <a:solidFill>
+                  <a:schemeClr val="bg1"/>
+                </a:solidFill>
+              </a:rPr>
+              <a:t>classical | CNN</a:t>
+            </a:r>
+            <a:endParaRPr lang="en-US" sz="1200" dirty="0"/>
+          </a:p>
+        </p:txBody>
+      </p:sp>
+      <p:sp>
+        <p:nvSpPr>
+          <p:cNvPr id="16" name="Shape 14"/>
+          <p:cNvSpPr/>
+          <p:nvPr/>
+        </p:nvSpPr>
+        <p:spPr>
+          <a:xfrm>
+            <a:off x="7955280" y="3749040"/>
+            <a:ext cx="502920" cy="0"/>
+          </a:xfrm>
+          <a:prstGeom prst="line">
+            <a:avLst/>
+          </a:prstGeom>
+          <a:noFill/>
+          <a:ln w="28575">
+            <a:solidFill>
+              <a:srgbClr val="0B2545"/>
+            </a:solidFill>
+            <a:prstDash val="solid"/>
+            <a:tailEnd type="triangle"/>
+          </a:ln>
+        </p:spPr>
+      </p:sp>
+      <p:sp>
+        <p:nvSpPr>
+          <p:cNvPr id="17" name="Output card"/>
+          <p:cNvSpPr/>
+          <p:nvPr/>
+        </p:nvSpPr>
+        <p:spPr>
+          <a:xfrm>
+            <a:off x="8549640" y="2103120"/>
+            <a:ext cx="2999232" cy="3200400"/>
+          </a:xfrm>
+          <a:prstGeom prst="roundRect">
+            <a:avLst>
+              <a:gd name="adj" fmla="val 3659"/>
+            </a:avLst>
+          </a:prstGeom>
+          <a:solidFill>
+            <a:schemeClr val="bg2"/>
+          </a:solidFill>
+          <a:ln/>
+        </p:spPr>
+      </p:sp>
+      <p:sp>
+        <p:nvSpPr>
+          <p:cNvPr id="18" name="Text 16"/>
+          <p:cNvSpPr txBox="1"/>
+          <p:nvPr/>
+        </p:nvSpPr>
+        <p:spPr>
+          <a:xfrm>
+            <a:off x="8778240" y="2267712"/>
+            <a:ext cx="2560320" cy="274320"/>
+          </a:xfrm>
+          <a:prstGeom prst="rect">
+            <a:avLst/>
+          </a:prstGeom>
+          <a:noFill/>
+          <a:ln/>
+        </p:spPr>
+        <p:txBody>
+          <a:bodyPr wrap="square" lIns="0" tIns="0" rIns="0" bIns="0" rtlCol="0" anchor="t"/>
+          <a:lstStyle/>
+          <a:p>
             <a:pPr indent="0" marL="0">
               <a:buNone/>
             </a:pPr>
             <a:r>
-              <a:rPr lang="en-US" sz="3000" b="1" dirty="0">
-                <a:solidFill>
-                  <a:schemeClr val="bg1"/>
-                </a:solidFill>
-              </a:rPr>
-              <a:t>No baseline, no score.</a:t>
-            </a:r>
-            <a:endParaRPr lang="en-US" sz="3000" dirty="0"/>
-          </a:p>
-        </p:txBody>
-      </p:sp>
-      <p:sp>
-        <p:nvSpPr>
-          <p:cNvPr id="24" name="Text 19"/>
-          <p:cNvSpPr txBox="1"/>
-          <p:nvPr/>
-        </p:nvSpPr>
-        <p:spPr>
-          <a:xfrm>
-            <a:off x="5669280" y="4617720"/>
-            <a:ext cx="5577840" cy="1508760"/>
-          </a:xfrm>
-          <a:prstGeom prst="rect">
-            <a:avLst/>
-          </a:prstGeom>
-          <a:noFill/>
-          <a:ln/>
-        </p:spPr>
-        <p:txBody>
-          <a:bodyPr wrap="square" lIns="0" tIns="0" rIns="0" bIns="0" rtlCol="0" anchor="ctr"/>
+              <a:rPr lang="en-US" sz="1200" b="1" spc="200" kern="0" dirty="0">
+                <a:solidFill>
+                  <a:schemeClr val="accent6"/>
+                </a:solidFill>
+              </a:rPr>
+              <a:t>8 RHYTHM CLASSES</a:t>
+            </a:r>
+            <a:endParaRPr lang="en-US" sz="1200" dirty="0"/>
+          </a:p>
+        </p:txBody>
+      </p:sp>
+      <p:sp>
+        <p:nvSpPr>
+          <p:cNvPr id="19" name="Text 17"/>
+          <p:cNvSpPr txBox="1"/>
+          <p:nvPr/>
+        </p:nvSpPr>
+        <p:spPr>
+          <a:xfrm>
+            <a:off x="8778240" y="2633472"/>
+            <a:ext cx="2651760" cy="2560320"/>
+          </a:xfrm>
+          <a:prstGeom prst="rect">
+            <a:avLst/>
+          </a:prstGeom>
+          <a:noFill/>
+          <a:ln/>
+        </p:spPr>
+        <p:txBody>
+          <a:bodyPr wrap="square" lIns="0" tIns="0" rIns="0" bIns="0" rtlCol="0" anchor="t"/>
           <a:lstStyle/>
           <a:p>
             <a:pPr indent="0" marL="0">
-              <a:buNone/>
-            </a:pPr>
-            <a:r>
-              <a:rPr lang="en-US" sz="1600" dirty="0">
-                <a:solidFill>
-                  <a:schemeClr val="bg1"/>
-                </a:solidFill>
-              </a:rPr>
-              <a:t>Uncalibrated users see "Personal baseline required" instead of a guess from population averages. Baselines expire after 30 days or when the device changes.</a:t>
+              <a:spcAft>
+                <a:spcPts val="300"/>
+              </a:spcAft>
+              <a:buNone/>
+            </a:pPr>
+            <a:r>
+              <a:rPr lang="en-US" sz="1400" dirty="0">
+                <a:solidFill>
+                  <a:schemeClr val="tx1"/>
+                </a:solidFill>
+              </a:rPr>
+              <a:t>Normal</a:t>
+            </a:r>
+            <a:endParaRPr lang="en-US" sz="1400" dirty="0"/>
+          </a:p>
+          <a:p>
+            <a:pPr indent="0" marL="0">
+              <a:spcAft>
+                <a:spcPts val="300"/>
+              </a:spcAft>
+              <a:buNone/>
+            </a:pPr>
+            <a:r>
+              <a:rPr lang="en-US" sz="1400" dirty="0">
+                <a:solidFill>
+                  <a:schemeClr val="tx1"/>
+                </a:solidFill>
+              </a:rPr>
+              <a:t>Tachycardia</a:t>
+            </a:r>
+            <a:endParaRPr lang="en-US" sz="1400" dirty="0"/>
+          </a:p>
+          <a:p>
+            <a:pPr indent="0" marL="0">
+              <a:spcAft>
+                <a:spcPts val="300"/>
+              </a:spcAft>
+              <a:buNone/>
+            </a:pPr>
+            <a:r>
+              <a:rPr lang="en-US" sz="1400" dirty="0">
+                <a:solidFill>
+                  <a:schemeClr val="tx1"/>
+                </a:solidFill>
+              </a:rPr>
+              <a:t>Bradycardia</a:t>
+            </a:r>
+            <a:endParaRPr lang="en-US" sz="1400" dirty="0"/>
+          </a:p>
+          <a:p>
+            <a:pPr indent="0" marL="0">
+              <a:spcAft>
+                <a:spcPts val="300"/>
+              </a:spcAft>
+              <a:buNone/>
+            </a:pPr>
+            <a:r>
+              <a:rPr lang="en-US" sz="1400" dirty="0">
+                <a:solidFill>
+                  <a:schemeClr val="tx1"/>
+                </a:solidFill>
+              </a:rPr>
+              <a:t>AFib</a:t>
+            </a:r>
+            <a:endParaRPr lang="en-US" sz="1400" dirty="0"/>
+          </a:p>
+          <a:p>
+            <a:pPr indent="0" marL="0">
+              <a:spcAft>
+                <a:spcPts val="300"/>
+              </a:spcAft>
+              <a:buNone/>
+            </a:pPr>
+            <a:r>
+              <a:rPr lang="en-US" sz="1400" dirty="0">
+                <a:solidFill>
+                  <a:schemeClr val="tx1"/>
+                </a:solidFill>
+              </a:rPr>
+              <a:t>Cardiac paced</a:t>
+            </a:r>
+            <a:endParaRPr lang="en-US" sz="1400" dirty="0"/>
+          </a:p>
+          <a:p>
+            <a:pPr indent="0" marL="0">
+              <a:spcAft>
+                <a:spcPts val="300"/>
+              </a:spcAft>
+              <a:buNone/>
+            </a:pPr>
+            <a:r>
+              <a:rPr lang="en-US" sz="1400" dirty="0">
+                <a:solidFill>
+                  <a:schemeClr val="tx1"/>
+                </a:solidFill>
+              </a:rPr>
+              <a:t>V. tachycardia</a:t>
+            </a:r>
+            <a:endParaRPr lang="en-US" sz="1400" dirty="0"/>
+          </a:p>
+          <a:p>
+            <a:pPr indent="0" marL="0">
+              <a:spcAft>
+                <a:spcPts val="300"/>
+              </a:spcAft>
+              <a:buNone/>
+            </a:pPr>
+            <a:r>
+              <a:rPr lang="en-US" sz="1400" dirty="0">
+                <a:solidFill>
+                  <a:schemeClr val="tx1"/>
+                </a:solidFill>
+              </a:rPr>
+              <a:t>V. flutter / fib</a:t>
+            </a:r>
+            <a:endParaRPr lang="en-US" sz="1400" dirty="0"/>
+          </a:p>
+          <a:p>
+            <a:pPr indent="0" marL="0">
+              <a:spcAft>
+                <a:spcPts val="300"/>
+              </a:spcAft>
+              <a:buNone/>
+            </a:pPr>
+            <a:r>
+              <a:rPr lang="en-US" sz="1400" dirty="0">
+                <a:solidFill>
+                  <a:schemeClr val="tx1"/>
+                </a:solidFill>
+              </a:rPr>
+              <a:t>Asystole</a:t>
+            </a:r>
+            <a:endParaRPr lang="en-US" sz="1400" dirty="0"/>
+          </a:p>
+        </p:txBody>
+      </p:sp>
+      <p:sp>
+        <p:nvSpPr>
+          <p:cNvPr id="20" name="Text 18"/>
+          <p:cNvSpPr txBox="1"/>
+          <p:nvPr/>
+        </p:nvSpPr>
+        <p:spPr>
+          <a:xfrm>
+            <a:off x="640080" y="5577840"/>
+            <a:ext cx="10908792" cy="548640"/>
+          </a:xfrm>
+          <a:prstGeom prst="rect">
+            <a:avLst/>
+          </a:prstGeom>
+          <a:noFill/>
+          <a:ln/>
+        </p:spPr>
+        <p:txBody>
+          <a:bodyPr wrap="square" lIns="0" tIns="0" rIns="0" bIns="0" rtlCol="0" anchor="t"/>
+          <a:lstStyle/>
+          <a:p>
+            <a:pPr indent="0" marL="0">
+              <a:buNone/>
+            </a:pPr>
+            <a:r>
+              <a:rPr lang="en-US" sz="1600" b="1" dirty="0">
+                <a:solidFill>
+                  <a:schemeClr val="tx2"/>
+                </a:solidFill>
+              </a:rPr>
+              <a:t>Hand-built HRV statistics capture physiology. The CNN captures waveform shape the statistics miss.</a:t>
             </a:r>
             <a:endParaRPr lang="en-US" sz="1600" dirty="0"/>
           </a:p>
@@ -11178,7 +11346,7 @@
                   <a:schemeClr val="accent1"/>
                 </a:solidFill>
               </a:rPr>
-              <a:t>STAGE 3  ·  DUAL-MODALITY AI</a:t>
+              <a:t>STAGE 4  ·  DIGITAL TWIN</a:t>
             </a:r>
             <a:endParaRPr lang="en-US" sz="1200" dirty="0"/>
           </a:p>
@@ -11216,7 +11384,7 @@
                   <a:schemeClr val="tx2"/>
                 </a:solidFill>
               </a:rPr>
-              <a:t>Two ways of seeing one heartbeat, fused into one answer</a:t>
+              <a:t>Your heart, compared with your own heart</a:t>
             </a:r>
             <a:endParaRPr lang="en-US" sz="3400" dirty="0"/>
           </a:p>
@@ -11224,18 +11392,546 @@
       </p:sp>
       <p:sp>
         <p:nvSpPr>
-          <p:cNvPr id="4" name="Classical card"/>
+          <p:cNvPr id="4" name="Step card 1"/>
           <p:cNvSpPr/>
           <p:nvPr/>
         </p:nvSpPr>
         <p:spPr>
           <a:xfrm>
-            <a:off x="640080" y="2103120"/>
-            <a:ext cx="4297680" cy="1508760"/>
+            <a:off x="640080" y="2011680"/>
+            <a:ext cx="3429000" cy="1737360"/>
           </a:xfrm>
           <a:prstGeom prst="roundRect">
             <a:avLst>
-              <a:gd name="adj" fmla="val 7273"/>
+              <a:gd name="adj" fmla="val 6316"/>
+            </a:avLst>
+          </a:prstGeom>
+          <a:solidFill>
+            <a:schemeClr val="bg2"/>
+          </a:solidFill>
+          <a:ln/>
+        </p:spPr>
+      </p:sp>
+      <p:sp>
+        <p:nvSpPr>
+          <p:cNvPr id="5" name="Sit for 2 minutes icon circle"/>
+          <p:cNvSpPr/>
+          <p:nvPr/>
+        </p:nvSpPr>
+        <p:spPr>
+          <a:xfrm>
+            <a:off x="914400" y="2148840"/>
+            <a:ext cx="502920" cy="502920"/>
+          </a:xfrm>
+          <a:prstGeom prst="ellipse">
+            <a:avLst/>
+          </a:prstGeom>
+          <a:solidFill>
+            <a:schemeClr val="accent1">
+              <a:alpha val="15000"/>
+            </a:schemeClr>
+          </a:solidFill>
+          <a:ln/>
+        </p:spPr>
+      </p:sp>
+      <p:pic>
+        <p:nvPicPr>
+          <p:cNvPr id="6" name="Sit for 2 minutes icon" descr="Sit for 2 minutes icon">    </p:cNvPr>
+          <p:cNvPicPr>
+            <a:picLocks noChangeAspect="1"/>
+          </p:cNvPicPr>
+          <p:nvPr/>
+        </p:nvPicPr>
+        <p:blipFill>
+          <a:blip r:embed="rId1"/>
+          <a:stretch>
+            <a:fillRect/>
+          </a:stretch>
+        </p:blipFill>
+        <p:spPr>
+          <a:xfrm>
+            <a:off x="1040130" y="2274570"/>
+            <a:ext cx="251460" cy="251460"/>
+          </a:xfrm>
+          <a:prstGeom prst="rect">
+            <a:avLst/>
+          </a:prstGeom>
+        </p:spPr>
+      </p:pic>
+      <p:sp>
+        <p:nvSpPr>
+          <p:cNvPr id="7" name="Text 4"/>
+          <p:cNvSpPr txBox="1"/>
+          <p:nvPr/>
+        </p:nvSpPr>
+        <p:spPr>
+          <a:xfrm>
+            <a:off x="3291840" y="2240280"/>
+            <a:ext cx="502920" cy="365760"/>
+          </a:xfrm>
+          <a:prstGeom prst="rect">
+            <a:avLst/>
+          </a:prstGeom>
+          <a:noFill/>
+          <a:ln/>
+        </p:spPr>
+        <p:txBody>
+          <a:bodyPr wrap="square" lIns="0" tIns="0" rIns="0" bIns="0" rtlCol="0" anchor="t"/>
+          <a:lstStyle/>
+          <a:p>
+            <a:pPr algn="r" indent="0" marL="0">
+              <a:buNone/>
+            </a:pPr>
+            <a:r>
+              <a:rPr lang="en-US" sz="1800" b="1" dirty="0">
+                <a:solidFill>
+                  <a:schemeClr val="accent6"/>
+                </a:solidFill>
+              </a:rPr>
+              <a:t>1</a:t>
+            </a:r>
+            <a:endParaRPr lang="en-US" sz="1800" dirty="0"/>
+          </a:p>
+        </p:txBody>
+      </p:sp>
+      <p:sp>
+        <p:nvSpPr>
+          <p:cNvPr id="8" name="Text 5"/>
+          <p:cNvSpPr txBox="1"/>
+          <p:nvPr/>
+        </p:nvSpPr>
+        <p:spPr>
+          <a:xfrm>
+            <a:off x="914400" y="2788920"/>
+            <a:ext cx="2926080" cy="365760"/>
+          </a:xfrm>
+          <a:prstGeom prst="rect">
+            <a:avLst/>
+          </a:prstGeom>
+          <a:noFill/>
+          <a:ln/>
+        </p:spPr>
+        <p:txBody>
+          <a:bodyPr wrap="square" lIns="0" tIns="0" rIns="0" bIns="0" rtlCol="0" anchor="t"/>
+          <a:lstStyle/>
+          <a:p>
+            <a:pPr indent="0" marL="0">
+              <a:buNone/>
+            </a:pPr>
+            <a:r>
+              <a:rPr lang="en-US" sz="2000" b="1" dirty="0">
+                <a:solidFill>
+                  <a:schemeClr val="tx2"/>
+                </a:solidFill>
+              </a:rPr>
+              <a:t>Sit for 2 minutes</a:t>
+            </a:r>
+            <a:endParaRPr lang="en-US" sz="2000" dirty="0"/>
+          </a:p>
+        </p:txBody>
+      </p:sp>
+      <p:sp>
+        <p:nvSpPr>
+          <p:cNvPr id="9" name="Text 6"/>
+          <p:cNvSpPr txBox="1"/>
+          <p:nvPr/>
+        </p:nvSpPr>
+        <p:spPr>
+          <a:xfrm>
+            <a:off x="914400" y="3172968"/>
+            <a:ext cx="2880360" cy="548640"/>
+          </a:xfrm>
+          <a:prstGeom prst="rect">
+            <a:avLst/>
+          </a:prstGeom>
+          <a:noFill/>
+          <a:ln/>
+        </p:spPr>
+        <p:txBody>
+          <a:bodyPr wrap="square" lIns="0" tIns="0" rIns="0" bIns="0" rtlCol="0" anchor="t"/>
+          <a:lstStyle/>
+          <a:p>
+            <a:pPr indent="0" marL="0">
+              <a:buNone/>
+            </a:pPr>
+            <a:r>
+              <a:rPr lang="en-US" sz="1400" dirty="0">
+                <a:solidFill>
+                  <a:schemeClr val="tx1"/>
+                </a:solidFill>
+              </a:rPr>
+              <a:t>At least 6 clean 10-second windows of seated rest</a:t>
+            </a:r>
+            <a:endParaRPr lang="en-US" sz="1400" dirty="0"/>
+          </a:p>
+        </p:txBody>
+      </p:sp>
+      <p:sp>
+        <p:nvSpPr>
+          <p:cNvPr id="10" name="Step card 2"/>
+          <p:cNvSpPr/>
+          <p:nvPr/>
+        </p:nvSpPr>
+        <p:spPr>
+          <a:xfrm>
+            <a:off x="4379976" y="2011680"/>
+            <a:ext cx="3429000" cy="1737360"/>
+          </a:xfrm>
+          <a:prstGeom prst="roundRect">
+            <a:avLst>
+              <a:gd name="adj" fmla="val 6316"/>
+            </a:avLst>
+          </a:prstGeom>
+          <a:solidFill>
+            <a:schemeClr val="bg2"/>
+          </a:solidFill>
+          <a:ln/>
+        </p:spPr>
+      </p:sp>
+      <p:sp>
+        <p:nvSpPr>
+          <p:cNvPr id="11" name="Learn your fingerprint icon circle"/>
+          <p:cNvSpPr/>
+          <p:nvPr/>
+        </p:nvSpPr>
+        <p:spPr>
+          <a:xfrm>
+            <a:off x="4654296" y="2148840"/>
+            <a:ext cx="502920" cy="502920"/>
+          </a:xfrm>
+          <a:prstGeom prst="ellipse">
+            <a:avLst/>
+          </a:prstGeom>
+          <a:solidFill>
+            <a:schemeClr val="accent1">
+              <a:alpha val="15000"/>
+            </a:schemeClr>
+          </a:solidFill>
+          <a:ln/>
+        </p:spPr>
+      </p:sp>
+      <p:pic>
+        <p:nvPicPr>
+          <p:cNvPr id="12" name="Learn your fingerprint icon" descr="Learn your fingerprint icon">    </p:cNvPr>
+          <p:cNvPicPr>
+            <a:picLocks noChangeAspect="1"/>
+          </p:cNvPicPr>
+          <p:nvPr/>
+        </p:nvPicPr>
+        <p:blipFill>
+          <a:blip r:embed="rId2"/>
+          <a:stretch>
+            <a:fillRect/>
+          </a:stretch>
+        </p:blipFill>
+        <p:spPr>
+          <a:xfrm>
+            <a:off x="4780026" y="2274570"/>
+            <a:ext cx="251460" cy="251460"/>
+          </a:xfrm>
+          <a:prstGeom prst="rect">
+            <a:avLst/>
+          </a:prstGeom>
+        </p:spPr>
+      </p:pic>
+      <p:sp>
+        <p:nvSpPr>
+          <p:cNvPr id="13" name="Text 9"/>
+          <p:cNvSpPr txBox="1"/>
+          <p:nvPr/>
+        </p:nvSpPr>
+        <p:spPr>
+          <a:xfrm>
+            <a:off x="7031736" y="2240280"/>
+            <a:ext cx="502920" cy="365760"/>
+          </a:xfrm>
+          <a:prstGeom prst="rect">
+            <a:avLst/>
+          </a:prstGeom>
+          <a:noFill/>
+          <a:ln/>
+        </p:spPr>
+        <p:txBody>
+          <a:bodyPr wrap="square" lIns="0" tIns="0" rIns="0" bIns="0" rtlCol="0" anchor="t"/>
+          <a:lstStyle/>
+          <a:p>
+            <a:pPr algn="r" indent="0" marL="0">
+              <a:buNone/>
+            </a:pPr>
+            <a:r>
+              <a:rPr lang="en-US" sz="1800" b="1" dirty="0">
+                <a:solidFill>
+                  <a:schemeClr val="accent6"/>
+                </a:solidFill>
+              </a:rPr>
+              <a:t>2</a:t>
+            </a:r>
+            <a:endParaRPr lang="en-US" sz="1800" dirty="0"/>
+          </a:p>
+        </p:txBody>
+      </p:sp>
+      <p:sp>
+        <p:nvSpPr>
+          <p:cNvPr id="14" name="Text 10"/>
+          <p:cNvSpPr txBox="1"/>
+          <p:nvPr/>
+        </p:nvSpPr>
+        <p:spPr>
+          <a:xfrm>
+            <a:off x="4654296" y="2788920"/>
+            <a:ext cx="2926080" cy="365760"/>
+          </a:xfrm>
+          <a:prstGeom prst="rect">
+            <a:avLst/>
+          </a:prstGeom>
+          <a:noFill/>
+          <a:ln/>
+        </p:spPr>
+        <p:txBody>
+          <a:bodyPr wrap="square" lIns="0" tIns="0" rIns="0" bIns="0" rtlCol="0" anchor="t"/>
+          <a:lstStyle/>
+          <a:p>
+            <a:pPr indent="0" marL="0">
+              <a:buNone/>
+            </a:pPr>
+            <a:r>
+              <a:rPr lang="en-US" sz="2000" b="1" dirty="0">
+                <a:solidFill>
+                  <a:schemeClr val="tx2"/>
+                </a:solidFill>
+              </a:rPr>
+              <a:t>Learn your fingerprint</a:t>
+            </a:r>
+            <a:endParaRPr lang="en-US" sz="2000" dirty="0"/>
+          </a:p>
+        </p:txBody>
+      </p:sp>
+      <p:sp>
+        <p:nvSpPr>
+          <p:cNvPr id="15" name="Text 11"/>
+          <p:cNvSpPr txBox="1"/>
+          <p:nvPr/>
+        </p:nvSpPr>
+        <p:spPr>
+          <a:xfrm>
+            <a:off x="4654296" y="3172968"/>
+            <a:ext cx="2880360" cy="548640"/>
+          </a:xfrm>
+          <a:prstGeom prst="rect">
+            <a:avLst/>
+          </a:prstGeom>
+          <a:noFill/>
+          <a:ln/>
+        </p:spPr>
+        <p:txBody>
+          <a:bodyPr wrap="square" lIns="0" tIns="0" rIns="0" bIns="0" rtlCol="0" anchor="t"/>
+          <a:lstStyle/>
+          <a:p>
+            <a:pPr indent="0" marL="0">
+              <a:buNone/>
+            </a:pPr>
+            <a:r>
+              <a:rPr lang="en-US" sz="1400" dirty="0">
+                <a:solidFill>
+                  <a:schemeClr val="tx1"/>
+                </a:solidFill>
+              </a:rPr>
+              <a:t>Median and MAD of BPM, RR variability and RMSSD</a:t>
+            </a:r>
+            <a:endParaRPr lang="en-US" sz="1400" dirty="0"/>
+          </a:p>
+        </p:txBody>
+      </p:sp>
+      <p:sp>
+        <p:nvSpPr>
+          <p:cNvPr id="16" name="Step card 3"/>
+          <p:cNvSpPr/>
+          <p:nvPr/>
+        </p:nvSpPr>
+        <p:spPr>
+          <a:xfrm>
+            <a:off x="8119872" y="2011680"/>
+            <a:ext cx="3429000" cy="1737360"/>
+          </a:xfrm>
+          <a:prstGeom prst="roundRect">
+            <a:avLst>
+              <a:gd name="adj" fmla="val 6316"/>
+            </a:avLst>
+          </a:prstGeom>
+          <a:solidFill>
+            <a:schemeClr val="bg2"/>
+          </a:solidFill>
+          <a:ln/>
+        </p:spPr>
+      </p:sp>
+      <p:sp>
+        <p:nvSpPr>
+          <p:cNvPr id="17" name="Score every departure icon circle"/>
+          <p:cNvSpPr/>
+          <p:nvPr/>
+        </p:nvSpPr>
+        <p:spPr>
+          <a:xfrm>
+            <a:off x="8394192" y="2148840"/>
+            <a:ext cx="502920" cy="502920"/>
+          </a:xfrm>
+          <a:prstGeom prst="ellipse">
+            <a:avLst/>
+          </a:prstGeom>
+          <a:solidFill>
+            <a:schemeClr val="accent1">
+              <a:alpha val="15000"/>
+            </a:schemeClr>
+          </a:solidFill>
+          <a:ln/>
+        </p:spPr>
+      </p:sp>
+      <p:pic>
+        <p:nvPicPr>
+          <p:cNvPr id="18" name="Score every departure icon" descr="Score every departure icon">    </p:cNvPr>
+          <p:cNvPicPr>
+            <a:picLocks noChangeAspect="1"/>
+          </p:cNvPicPr>
+          <p:nvPr/>
+        </p:nvPicPr>
+        <p:blipFill>
+          <a:blip r:embed="rId3"/>
+          <a:stretch>
+            <a:fillRect/>
+          </a:stretch>
+        </p:blipFill>
+        <p:spPr>
+          <a:xfrm>
+            <a:off x="8519922" y="2274570"/>
+            <a:ext cx="251460" cy="251460"/>
+          </a:xfrm>
+          <a:prstGeom prst="rect">
+            <a:avLst/>
+          </a:prstGeom>
+        </p:spPr>
+      </p:pic>
+      <p:sp>
+        <p:nvSpPr>
+          <p:cNvPr id="19" name="Text 14"/>
+          <p:cNvSpPr txBox="1"/>
+          <p:nvPr/>
+        </p:nvSpPr>
+        <p:spPr>
+          <a:xfrm>
+            <a:off x="10771632" y="2240280"/>
+            <a:ext cx="502920" cy="365760"/>
+          </a:xfrm>
+          <a:prstGeom prst="rect">
+            <a:avLst/>
+          </a:prstGeom>
+          <a:noFill/>
+          <a:ln/>
+        </p:spPr>
+        <p:txBody>
+          <a:bodyPr wrap="square" lIns="0" tIns="0" rIns="0" bIns="0" rtlCol="0" anchor="t"/>
+          <a:lstStyle/>
+          <a:p>
+            <a:pPr algn="r" indent="0" marL="0">
+              <a:buNone/>
+            </a:pPr>
+            <a:r>
+              <a:rPr lang="en-US" sz="1800" b="1" dirty="0">
+                <a:solidFill>
+                  <a:schemeClr val="accent6"/>
+                </a:solidFill>
+              </a:rPr>
+              <a:t>3</a:t>
+            </a:r>
+            <a:endParaRPr lang="en-US" sz="1800" dirty="0"/>
+          </a:p>
+        </p:txBody>
+      </p:sp>
+      <p:sp>
+        <p:nvSpPr>
+          <p:cNvPr id="20" name="Text 15"/>
+          <p:cNvSpPr txBox="1"/>
+          <p:nvPr/>
+        </p:nvSpPr>
+        <p:spPr>
+          <a:xfrm>
+            <a:off x="8394192" y="2788920"/>
+            <a:ext cx="2926080" cy="365760"/>
+          </a:xfrm>
+          <a:prstGeom prst="rect">
+            <a:avLst/>
+          </a:prstGeom>
+          <a:noFill/>
+          <a:ln/>
+        </p:spPr>
+        <p:txBody>
+          <a:bodyPr wrap="square" lIns="0" tIns="0" rIns="0" bIns="0" rtlCol="0" anchor="t"/>
+          <a:lstStyle/>
+          <a:p>
+            <a:pPr indent="0" marL="0">
+              <a:buNone/>
+            </a:pPr>
+            <a:r>
+              <a:rPr lang="en-US" sz="2000" b="1" dirty="0">
+                <a:solidFill>
+                  <a:schemeClr val="tx2"/>
+                </a:solidFill>
+              </a:rPr>
+              <a:t>Score every departure</a:t>
+            </a:r>
+            <a:endParaRPr lang="en-US" sz="2000" dirty="0"/>
+          </a:p>
+        </p:txBody>
+      </p:sp>
+      <p:sp>
+        <p:nvSpPr>
+          <p:cNvPr id="21" name="Text 16"/>
+          <p:cNvSpPr txBox="1"/>
+          <p:nvPr/>
+        </p:nvSpPr>
+        <p:spPr>
+          <a:xfrm>
+            <a:off x="8394192" y="3172968"/>
+            <a:ext cx="2880360" cy="548640"/>
+          </a:xfrm>
+          <a:prstGeom prst="rect">
+            <a:avLst/>
+          </a:prstGeom>
+          <a:noFill/>
+          <a:ln/>
+        </p:spPr>
+        <p:txBody>
+          <a:bodyPr wrap="square" lIns="0" tIns="0" rIns="0" bIns="0" rtlCol="0" anchor="t"/>
+          <a:lstStyle/>
+          <a:p>
+            <a:pPr indent="0" marL="0">
+              <a:buNone/>
+            </a:pPr>
+            <a:r>
+              <a:rPr lang="en-US" sz="1400" dirty="0">
+                <a:solidFill>
+                  <a:schemeClr val="tx1"/>
+                </a:solidFill>
+              </a:rPr>
+              <a:t>Instability Index 0–100, smoothed with EMA (α = 0.35)</a:t>
+            </a:r>
+            <a:endParaRPr lang="en-US" sz="1400" dirty="0"/>
+          </a:p>
+        </p:txBody>
+      </p:sp>
+      <p:sp>
+        <p:nvSpPr>
+          <p:cNvPr id="22" name="Phase 3 card 1"/>
+          <p:cNvSpPr/>
+          <p:nvPr/>
+        </p:nvSpPr>
+        <p:spPr>
+          <a:xfrm>
+            <a:off x="640080" y="3886200"/>
+            <a:ext cx="5340096" cy="1280160"/>
+          </a:xfrm>
+          <a:prstGeom prst="roundRect">
+            <a:avLst>
+              <a:gd name="adj" fmla="val 8571"/>
             </a:avLst>
           </a:prstGeom>
           <a:solidFill>
@@ -11248,14 +11944,14 @@
       </p:sp>
       <p:sp>
         <p:nvSpPr>
-          <p:cNvPr id="5" name="Text 3"/>
-          <p:cNvSpPr txBox="1"/>
-          <p:nvPr/>
-        </p:nvSpPr>
-        <p:spPr>
-          <a:xfrm>
-            <a:off x="914400" y="2240280"/>
-            <a:ext cx="3749040" cy="274320"/>
+          <p:cNvPr id="23" name="Text 18"/>
+          <p:cNvSpPr txBox="1"/>
+          <p:nvPr/>
+        </p:nvSpPr>
+        <p:spPr>
+          <a:xfrm>
+            <a:off x="914400" y="4023360"/>
+            <a:ext cx="4846320" cy="274320"/>
           </a:xfrm>
           <a:prstGeom prst="rect">
             <a:avLst/>
@@ -11271,12 +11967,12 @@
               <a:buNone/>
             </a:pPr>
             <a:r>
-              <a:rPr lang="en-US" sz="1200" b="1" spc="200" kern="0" dirty="0">
+              <a:rPr lang="en-US" sz="1200" b="1" spc="100" kern="0" dirty="0">
                 <a:solidFill>
                   <a:schemeClr val="accent1"/>
                 </a:solidFill>
               </a:rPr>
-              <a:t>CLASSICAL</a:t>
+              <a:t>EHR-COUPLED VULNERABILITY (M_EHR)</a:t>
             </a:r>
             <a:endParaRPr lang="en-US" sz="1200" dirty="0"/>
           </a:p>
@@ -11284,14 +11980,14 @@
       </p:sp>
       <p:sp>
         <p:nvSpPr>
-          <p:cNvPr id="6" name="Text 4"/>
-          <p:cNvSpPr txBox="1"/>
-          <p:nvPr/>
-        </p:nvSpPr>
-        <p:spPr>
-          <a:xfrm>
-            <a:off x="914400" y="2542032"/>
-            <a:ext cx="3749040" cy="411480"/>
+          <p:cNvPr id="24" name="Text 19"/>
+          <p:cNvSpPr txBox="1"/>
+          <p:nvPr/>
+        </p:nvSpPr>
+        <p:spPr>
+          <a:xfrm>
+            <a:off x="914400" y="4343400"/>
+            <a:ext cx="4846320" cy="777240"/>
           </a:xfrm>
           <a:prstGeom prst="rect">
             <a:avLst/>
@@ -11307,48 +12003,12 @@
               <a:buNone/>
             </a:pPr>
             <a:r>
-              <a:rPr lang="en-US" sz="2200" b="1" dirty="0">
-                <a:solidFill>
-                  <a:schemeClr val="tx2"/>
-                </a:solidFill>
-              </a:rPr>
-              <a:t>27 biomarkers</a:t>
-            </a:r>
-            <a:endParaRPr lang="en-US" sz="2200" dirty="0"/>
-          </a:p>
-        </p:txBody>
-      </p:sp>
-      <p:sp>
-        <p:nvSpPr>
-          <p:cNvPr id="7" name="Text 5"/>
-          <p:cNvSpPr txBox="1"/>
-          <p:nvPr/>
-        </p:nvSpPr>
-        <p:spPr>
-          <a:xfrm>
-            <a:off x="914400" y="3017520"/>
-            <a:ext cx="3840480" cy="457200"/>
-          </a:xfrm>
-          <a:prstGeom prst="rect">
-            <a:avLst/>
-          </a:prstGeom>
-          <a:noFill/>
-          <a:ln/>
-        </p:spPr>
-        <p:txBody>
-          <a:bodyPr wrap="square" lIns="0" tIns="0" rIns="0" bIns="0" rtlCol="0" anchor="t"/>
-          <a:lstStyle/>
-          <a:p>
-            <a:pPr indent="0" marL="0">
-              <a:buNone/>
-            </a:pPr>
-            <a:r>
               <a:rPr lang="en-US" sz="1400" dirty="0">
                 <a:solidFill>
                   <a:schemeClr val="tx1"/>
                 </a:solidFill>
               </a:rPr>
-              <a:t>XGBoost + Random Forest + ExtraTrees</a:t>
+              <a:t>Detects beta-blockade escape (BPM ≥ 90 on metoprolol), subclinical AFib prodrome and autonomic vagal withdrawal</a:t>
             </a:r>
             <a:endParaRPr lang="en-US" sz="1400" dirty="0"/>
           </a:p>
@@ -11356,18 +12016,18 @@
       </p:sp>
       <p:sp>
         <p:nvSpPr>
-          <p:cNvPr id="8" name="Deep learning card"/>
+          <p:cNvPr id="25" name="Phase 3 card 2"/>
           <p:cNvSpPr/>
           <p:nvPr/>
         </p:nvSpPr>
         <p:spPr>
           <a:xfrm>
-            <a:off x="640080" y="3794760"/>
-            <a:ext cx="4297680" cy="1508760"/>
+            <a:off x="6208776" y="3886200"/>
+            <a:ext cx="5340096" cy="1280160"/>
           </a:xfrm>
           <a:prstGeom prst="roundRect">
             <a:avLst>
-              <a:gd name="adj" fmla="val 7273"/>
+              <a:gd name="adj" fmla="val 8571"/>
             </a:avLst>
           </a:prstGeom>
           <a:solidFill>
@@ -11380,14 +12040,14 @@
       </p:sp>
       <p:sp>
         <p:nvSpPr>
-          <p:cNvPr id="9" name="Text 7"/>
-          <p:cNvSpPr txBox="1"/>
-          <p:nvPr/>
-        </p:nvSpPr>
-        <p:spPr>
-          <a:xfrm>
-            <a:off x="914400" y="3931920"/>
-            <a:ext cx="3749040" cy="274320"/>
+          <p:cNvPr id="26" name="Text 21"/>
+          <p:cNvSpPr txBox="1"/>
+          <p:nvPr/>
+        </p:nvSpPr>
+        <p:spPr>
+          <a:xfrm>
+            <a:off x="6483096" y="4023360"/>
+            <a:ext cx="4846320" cy="274320"/>
           </a:xfrm>
           <a:prstGeom prst="rect">
             <a:avLst/>
@@ -11403,12 +12063,12 @@
               <a:buNone/>
             </a:pPr>
             <a:r>
-              <a:rPr lang="en-US" sz="1200" b="1" spc="200" kern="0" dirty="0">
+              <a:rPr lang="en-US" sz="1200" b="1" spc="100" kern="0" dirty="0">
                 <a:solidFill>
                   <a:schemeClr val="accent4"/>
                 </a:solidFill>
               </a:rPr>
-              <a:t>DEEP LEARNING</a:t>
+              <a:t>PROACTIVE 2 h / 6 h EARLY WARNING</a:t>
             </a:r>
             <a:endParaRPr lang="en-US" sz="1200" dirty="0"/>
           </a:p>
@@ -11416,14 +12076,14 @@
       </p:sp>
       <p:sp>
         <p:nvSpPr>
-          <p:cNvPr id="10" name="Text 8"/>
-          <p:cNvSpPr txBox="1"/>
-          <p:nvPr/>
-        </p:nvSpPr>
-        <p:spPr>
-          <a:xfrm>
-            <a:off x="914400" y="4233672"/>
-            <a:ext cx="3840480" cy="411480"/>
+          <p:cNvPr id="27" name="Text 22"/>
+          <p:cNvSpPr txBox="1"/>
+          <p:nvPr/>
+        </p:nvSpPr>
+        <p:spPr>
+          <a:xfrm>
+            <a:off x="6483096" y="4343400"/>
+            <a:ext cx="4846320" cy="777240"/>
           </a:xfrm>
           <a:prstGeom prst="rect">
             <a:avLst/>
@@ -11439,48 +12099,12 @@
               <a:buNone/>
             </a:pPr>
             <a:r>
-              <a:rPr lang="en-US" sz="2200" b="1" dirty="0">
-                <a:solidFill>
-                  <a:schemeClr val="tx2"/>
-                </a:solidFill>
-              </a:rPr>
-              <a:t>Raw 1,000-sample waveform</a:t>
-            </a:r>
-            <a:endParaRPr lang="en-US" sz="2200" dirty="0"/>
-          </a:p>
-        </p:txBody>
-      </p:sp>
-      <p:sp>
-        <p:nvSpPr>
-          <p:cNvPr id="11" name="Text 9"/>
-          <p:cNvSpPr txBox="1"/>
-          <p:nvPr/>
-        </p:nvSpPr>
-        <p:spPr>
-          <a:xfrm>
-            <a:off x="914400" y="4709160"/>
-            <a:ext cx="3931920" cy="457200"/>
-          </a:xfrm>
-          <a:prstGeom prst="rect">
-            <a:avLst/>
-          </a:prstGeom>
-          <a:noFill/>
-          <a:ln/>
-        </p:spPr>
-        <p:txBody>
-          <a:bodyPr wrap="square" lIns="0" tIns="0" rIns="0" bIns="0" rtlCol="0" anchor="t"/>
-          <a:lstStyle/>
-          <a:p>
-            <a:pPr indent="0" marL="0">
-              <a:buNone/>
-            </a:pPr>
-            <a:r>
               <a:rPr lang="en-US" sz="1400" dirty="0">
                 <a:solidFill>
                   <a:schemeClr val="tx1"/>
                 </a:solidFill>
               </a:rPr>
-              <a:t>Inception-1D CNN  ·  4 kernel sizes  ·  393k params</a:t>
+              <a:t>Fuses 7-day nocturnal RMSSD and sleep-efficiency trends with acute PPG velocity to predict hemodynamic decompensation hours in advance</a:t>
             </a:r>
             <a:endParaRPr lang="en-US" sz="1400" dirty="0"/>
           </a:p>
@@ -11488,65 +12112,19 @@
       </p:sp>
       <p:sp>
         <p:nvSpPr>
-          <p:cNvPr id="12" name="Shape 10"/>
+          <p:cNvPr id="28" name="No baseline banner"/>
           <p:cNvSpPr/>
           <p:nvPr/>
         </p:nvSpPr>
         <p:spPr>
           <a:xfrm>
-            <a:off x="5029200" y="2852928"/>
-            <a:ext cx="731520" cy="731520"/>
-          </a:xfrm>
-          <a:prstGeom prst="line">
-            <a:avLst/>
-          </a:prstGeom>
-          <a:noFill/>
-          <a:ln w="28575">
-            <a:solidFill>
-              <a:srgbClr val="0E7490"/>
-            </a:solidFill>
-            <a:prstDash val="solid"/>
-            <a:tailEnd type="triangle"/>
-          </a:ln>
-        </p:spPr>
-      </p:sp>
-      <p:sp>
-        <p:nvSpPr>
-          <p:cNvPr id="13" name="Shape 11"/>
-          <p:cNvSpPr/>
-          <p:nvPr/>
-        </p:nvSpPr>
-        <p:spPr>
-          <a:xfrm flipV="1">
-            <a:off x="5029200" y="3950208"/>
-            <a:ext cx="731520" cy="731520"/>
-          </a:xfrm>
-          <a:prstGeom prst="line">
-            <a:avLst/>
-          </a:prstGeom>
-          <a:noFill/>
-          <a:ln w="28575">
-            <a:solidFill>
-              <a:srgbClr val="3B5B92"/>
-            </a:solidFill>
-            <a:prstDash val="solid"/>
-            <a:tailEnd type="triangle"/>
-          </a:ln>
-        </p:spPr>
-      </p:sp>
-      <p:sp>
-        <p:nvSpPr>
-          <p:cNvPr id="14" name="Fusion circle"/>
-          <p:cNvSpPr/>
-          <p:nvPr/>
-        </p:nvSpPr>
-        <p:spPr>
-          <a:xfrm>
-            <a:off x="5852160" y="2743200"/>
-            <a:ext cx="2011680" cy="2011680"/>
-          </a:xfrm>
-          <a:prstGeom prst="ellipse">
-            <a:avLst/>
+            <a:off x="640080" y="5349240"/>
+            <a:ext cx="10908792" cy="822960"/>
+          </a:xfrm>
+          <a:prstGeom prst="roundRect">
+            <a:avLst>
+              <a:gd name="adj" fmla="val 13333"/>
+            </a:avLst>
           </a:prstGeom>
           <a:solidFill>
             <a:schemeClr val="tx2"/>
@@ -11556,14 +12134,14 @@
       </p:sp>
       <p:sp>
         <p:nvSpPr>
-          <p:cNvPr id="15" name="Text 13"/>
-          <p:cNvSpPr txBox="1"/>
-          <p:nvPr/>
-        </p:nvSpPr>
-        <p:spPr>
-          <a:xfrm>
-            <a:off x="5852160" y="2743200"/>
-            <a:ext cx="2011680" cy="2011680"/>
+          <p:cNvPr id="29" name="Text 24"/>
+          <p:cNvSpPr txBox="1"/>
+          <p:nvPr/>
+        </p:nvSpPr>
+        <p:spPr>
+          <a:xfrm>
+            <a:off x="1005840" y="5349240"/>
+            <a:ext cx="4023360" cy="822960"/>
           </a:xfrm>
           <a:prstGeom prst="rect">
             <a:avLst/>
@@ -11575,322 +12153,54 @@
           <a:bodyPr wrap="square" lIns="0" tIns="0" rIns="0" bIns="0" rtlCol="0" anchor="ctr"/>
           <a:lstStyle/>
           <a:p>
-            <a:pPr algn="ctr" indent="0" marL="0">
-              <a:buNone/>
-            </a:pPr>
-            <a:r>
-              <a:rPr lang="en-US" sz="1200" b="1" dirty="0">
-                <a:solidFill>
-                  <a:schemeClr val="accent5"/>
-                </a:solidFill>
-              </a:rPr>
-              <a:t>FUSION</a:t>
-            </a:r>
-            <a:endParaRPr lang="en-US" sz="1200" dirty="0"/>
-          </a:p>
-          <a:p>
-            <a:pPr algn="ctr" indent="0" marL="0">
-              <a:buNone/>
-            </a:pPr>
-            <a:r>
-              <a:rPr lang="en-US" sz="2200" b="1" dirty="0">
+            <a:pPr indent="0" marL="0">
+              <a:buNone/>
+            </a:pPr>
+            <a:r>
+              <a:rPr lang="en-US" sz="2600" b="1" dirty="0">
                 <a:solidFill>
                   <a:schemeClr val="bg1"/>
                 </a:solidFill>
               </a:rPr>
-              <a:t>0.38 | 0.62</a:t>
-            </a:r>
-            <a:endParaRPr lang="en-US" sz="1200" dirty="0"/>
-          </a:p>
-          <a:p>
-            <a:pPr algn="ctr" indent="0" marL="0">
-              <a:buNone/>
-            </a:pPr>
-            <a:r>
-              <a:rPr lang="en-US" sz="1200" dirty="0">
+              <a:t>No baseline, no score.</a:t>
+            </a:r>
+            <a:endParaRPr lang="en-US" sz="2600" dirty="0"/>
+          </a:p>
+        </p:txBody>
+      </p:sp>
+      <p:sp>
+        <p:nvSpPr>
+          <p:cNvPr id="30" name="Text 25"/>
+          <p:cNvSpPr txBox="1"/>
+          <p:nvPr/>
+        </p:nvSpPr>
+        <p:spPr>
+          <a:xfrm>
+            <a:off x="5120640" y="5349240"/>
+            <a:ext cx="6217920" cy="822960"/>
+          </a:xfrm>
+          <a:prstGeom prst="rect">
+            <a:avLst/>
+          </a:prstGeom>
+          <a:noFill/>
+          <a:ln/>
+        </p:spPr>
+        <p:txBody>
+          <a:bodyPr wrap="square" lIns="0" tIns="0" rIns="0" bIns="0" rtlCol="0" anchor="ctr"/>
+          <a:lstStyle/>
+          <a:p>
+            <a:pPr indent="0" marL="0">
+              <a:buNone/>
+            </a:pPr>
+            <a:r>
+              <a:rPr lang="en-US" sz="1400" dirty="0">
                 <a:solidFill>
                   <a:schemeClr val="bg1"/>
                 </a:solidFill>
               </a:rPr>
-              <a:t>classical | CNN</a:t>
-            </a:r>
-            <a:endParaRPr lang="en-US" sz="1200" dirty="0"/>
-          </a:p>
-        </p:txBody>
-      </p:sp>
-      <p:sp>
-        <p:nvSpPr>
-          <p:cNvPr id="16" name="Shape 14"/>
-          <p:cNvSpPr/>
-          <p:nvPr/>
-        </p:nvSpPr>
-        <p:spPr>
-          <a:xfrm>
-            <a:off x="7955280" y="3749040"/>
-            <a:ext cx="502920" cy="0"/>
-          </a:xfrm>
-          <a:prstGeom prst="line">
-            <a:avLst/>
-          </a:prstGeom>
-          <a:noFill/>
-          <a:ln w="28575">
-            <a:solidFill>
-              <a:srgbClr val="0B2545"/>
-            </a:solidFill>
-            <a:prstDash val="solid"/>
-            <a:tailEnd type="triangle"/>
-          </a:ln>
-        </p:spPr>
-      </p:sp>
-      <p:sp>
-        <p:nvSpPr>
-          <p:cNvPr id="17" name="Output card"/>
-          <p:cNvSpPr/>
-          <p:nvPr/>
-        </p:nvSpPr>
-        <p:spPr>
-          <a:xfrm>
-            <a:off x="8549640" y="2103120"/>
-            <a:ext cx="2999232" cy="3200400"/>
-          </a:xfrm>
-          <a:prstGeom prst="roundRect">
-            <a:avLst>
-              <a:gd name="adj" fmla="val 3659"/>
-            </a:avLst>
-          </a:prstGeom>
-          <a:solidFill>
-            <a:schemeClr val="bg2"/>
-          </a:solidFill>
-          <a:ln/>
-        </p:spPr>
-      </p:sp>
-      <p:sp>
-        <p:nvSpPr>
-          <p:cNvPr id="18" name="Text 16"/>
-          <p:cNvSpPr txBox="1"/>
-          <p:nvPr/>
-        </p:nvSpPr>
-        <p:spPr>
-          <a:xfrm>
-            <a:off x="8778240" y="2267712"/>
-            <a:ext cx="2560320" cy="274320"/>
-          </a:xfrm>
-          <a:prstGeom prst="rect">
-            <a:avLst/>
-          </a:prstGeom>
-          <a:noFill/>
-          <a:ln/>
-        </p:spPr>
-        <p:txBody>
-          <a:bodyPr wrap="square" lIns="0" tIns="0" rIns="0" bIns="0" rtlCol="0" anchor="t"/>
-          <a:lstStyle/>
-          <a:p>
-            <a:pPr indent="0" marL="0">
-              <a:buNone/>
-            </a:pPr>
-            <a:r>
-              <a:rPr lang="en-US" sz="1200" b="1" spc="200" kern="0" dirty="0">
-                <a:solidFill>
-                  <a:schemeClr val="accent6"/>
-                </a:solidFill>
-              </a:rPr>
-              <a:t>8 RHYTHM CLASSES</a:t>
-            </a:r>
-            <a:endParaRPr lang="en-US" sz="1200" dirty="0"/>
-          </a:p>
-        </p:txBody>
-      </p:sp>
-      <p:sp>
-        <p:nvSpPr>
-          <p:cNvPr id="19" name="Text 17"/>
-          <p:cNvSpPr txBox="1"/>
-          <p:nvPr/>
-        </p:nvSpPr>
-        <p:spPr>
-          <a:xfrm>
-            <a:off x="8778240" y="2633472"/>
-            <a:ext cx="2651760" cy="2560320"/>
-          </a:xfrm>
-          <a:prstGeom prst="rect">
-            <a:avLst/>
-          </a:prstGeom>
-          <a:noFill/>
-          <a:ln/>
-        </p:spPr>
-        <p:txBody>
-          <a:bodyPr wrap="square" lIns="0" tIns="0" rIns="0" bIns="0" rtlCol="0" anchor="t"/>
-          <a:lstStyle/>
-          <a:p>
-            <a:pPr indent="0" marL="0">
-              <a:spcAft>
-                <a:spcPts val="300"/>
-              </a:spcAft>
-              <a:buNone/>
-            </a:pPr>
-            <a:r>
-              <a:rPr lang="en-US" sz="1400" dirty="0">
-                <a:solidFill>
-                  <a:schemeClr val="tx1"/>
-                </a:solidFill>
-              </a:rPr>
-              <a:t>Normal</a:t>
+              <a:t>Uncalibrated users see "Personal baseline required" instead of a guess from population averages. Baselines expire after 30 days or when the device changes.</a:t>
             </a:r>
             <a:endParaRPr lang="en-US" sz="1400" dirty="0"/>
-          </a:p>
-          <a:p>
-            <a:pPr indent="0" marL="0">
-              <a:spcAft>
-                <a:spcPts val="300"/>
-              </a:spcAft>
-              <a:buNone/>
-            </a:pPr>
-            <a:r>
-              <a:rPr lang="en-US" sz="1400" dirty="0">
-                <a:solidFill>
-                  <a:schemeClr val="tx1"/>
-                </a:solidFill>
-              </a:rPr>
-              <a:t>Tachycardia</a:t>
-            </a:r>
-            <a:endParaRPr lang="en-US" sz="1400" dirty="0"/>
-          </a:p>
-          <a:p>
-            <a:pPr indent="0" marL="0">
-              <a:spcAft>
-                <a:spcPts val="300"/>
-              </a:spcAft>
-              <a:buNone/>
-            </a:pPr>
-            <a:r>
-              <a:rPr lang="en-US" sz="1400" dirty="0">
-                <a:solidFill>
-                  <a:schemeClr val="tx1"/>
-                </a:solidFill>
-              </a:rPr>
-              <a:t>Bradycardia</a:t>
-            </a:r>
-            <a:endParaRPr lang="en-US" sz="1400" dirty="0"/>
-          </a:p>
-          <a:p>
-            <a:pPr indent="0" marL="0">
-              <a:spcAft>
-                <a:spcPts val="300"/>
-              </a:spcAft>
-              <a:buNone/>
-            </a:pPr>
-            <a:r>
-              <a:rPr lang="en-US" sz="1400" dirty="0">
-                <a:solidFill>
-                  <a:schemeClr val="tx1"/>
-                </a:solidFill>
-              </a:rPr>
-              <a:t>AFib</a:t>
-            </a:r>
-            <a:endParaRPr lang="en-US" sz="1400" dirty="0"/>
-          </a:p>
-          <a:p>
-            <a:pPr indent="0" marL="0">
-              <a:spcAft>
-                <a:spcPts val="300"/>
-              </a:spcAft>
-              <a:buNone/>
-            </a:pPr>
-            <a:r>
-              <a:rPr lang="en-US" sz="1400" dirty="0">
-                <a:solidFill>
-                  <a:schemeClr val="tx1"/>
-                </a:solidFill>
-              </a:rPr>
-              <a:t>Cardiac paced</a:t>
-            </a:r>
-            <a:endParaRPr lang="en-US" sz="1400" dirty="0"/>
-          </a:p>
-          <a:p>
-            <a:pPr indent="0" marL="0">
-              <a:spcAft>
-                <a:spcPts val="300"/>
-              </a:spcAft>
-              <a:buNone/>
-            </a:pPr>
-            <a:r>
-              <a:rPr lang="en-US" sz="1400" dirty="0">
-                <a:solidFill>
-                  <a:schemeClr val="tx1"/>
-                </a:solidFill>
-              </a:rPr>
-              <a:t>V. tachycardia</a:t>
-            </a:r>
-            <a:endParaRPr lang="en-US" sz="1400" dirty="0"/>
-          </a:p>
-          <a:p>
-            <a:pPr indent="0" marL="0">
-              <a:spcAft>
-                <a:spcPts val="300"/>
-              </a:spcAft>
-              <a:buNone/>
-            </a:pPr>
-            <a:r>
-              <a:rPr lang="en-US" sz="1400" dirty="0">
-                <a:solidFill>
-                  <a:schemeClr val="tx1"/>
-                </a:solidFill>
-              </a:rPr>
-              <a:t>V. flutter / fib</a:t>
-            </a:r>
-            <a:endParaRPr lang="en-US" sz="1400" dirty="0"/>
-          </a:p>
-          <a:p>
-            <a:pPr indent="0" marL="0">
-              <a:spcAft>
-                <a:spcPts val="300"/>
-              </a:spcAft>
-              <a:buNone/>
-            </a:pPr>
-            <a:r>
-              <a:rPr lang="en-US" sz="1400" dirty="0">
-                <a:solidFill>
-                  <a:schemeClr val="tx1"/>
-                </a:solidFill>
-              </a:rPr>
-              <a:t>Asystole</a:t>
-            </a:r>
-            <a:endParaRPr lang="en-US" sz="1400" dirty="0"/>
-          </a:p>
-        </p:txBody>
-      </p:sp>
-      <p:sp>
-        <p:nvSpPr>
-          <p:cNvPr id="20" name="Text 18"/>
-          <p:cNvSpPr txBox="1"/>
-          <p:nvPr/>
-        </p:nvSpPr>
-        <p:spPr>
-          <a:xfrm>
-            <a:off x="640080" y="5577840"/>
-            <a:ext cx="10908792" cy="548640"/>
-          </a:xfrm>
-          <a:prstGeom prst="rect">
-            <a:avLst/>
-          </a:prstGeom>
-          <a:noFill/>
-          <a:ln/>
-        </p:spPr>
-        <p:txBody>
-          <a:bodyPr wrap="square" lIns="0" tIns="0" rIns="0" bIns="0" rtlCol="0" anchor="t"/>
-          <a:lstStyle/>
-          <a:p>
-            <a:pPr indent="0" marL="0">
-              <a:buNone/>
-            </a:pPr>
-            <a:r>
-              <a:rPr lang="en-US" sz="1600" b="1" dirty="0">
-                <a:solidFill>
-                  <a:schemeClr val="tx2"/>
-                </a:solidFill>
-              </a:rPr>
-              <a:t>Hand-built HRV statistics capture physiology. The CNN captures waveform shape the statistics miss.</a:t>
-            </a:r>
-            <a:endParaRPr lang="en-US" sz="1600" dirty="0"/>
           </a:p>
         </p:txBody>
       </p:sp>
@@ -12916,7 +13226,7 @@
         </p:nvSpPr>
         <p:spPr>
           <a:xfrm>
-            <a:off x="5669280" y="2606040"/>
+            <a:off x="5669280" y="2514600"/>
             <a:ext cx="2286000" cy="411480"/>
           </a:xfrm>
           <a:prstGeom prst="rect">
@@ -12952,7 +13262,7 @@
         </p:nvSpPr>
         <p:spPr>
           <a:xfrm>
-            <a:off x="8001000" y="2715768"/>
+            <a:off x="8001000" y="2624328"/>
             <a:ext cx="2651760" cy="201168"/>
           </a:xfrm>
           <a:prstGeom prst="roundRect">
@@ -12974,7 +13284,7 @@
         </p:nvSpPr>
         <p:spPr>
           <a:xfrm>
-            <a:off x="8001000" y="2715768"/>
+            <a:off x="8001000" y="2624328"/>
             <a:ext cx="833410" cy="201168"/>
           </a:xfrm>
           <a:prstGeom prst="roundRect">
@@ -12998,7 +13308,7 @@
         </p:nvSpPr>
         <p:spPr>
           <a:xfrm>
-            <a:off x="8569234" y="2715768"/>
+            <a:off x="8569234" y="2624328"/>
             <a:ext cx="265176" cy="201168"/>
           </a:xfrm>
           <a:prstGeom prst="roundRect">
@@ -13020,7 +13330,7 @@
         </p:nvSpPr>
         <p:spPr>
           <a:xfrm>
-            <a:off x="10744200" y="2606040"/>
+            <a:off x="10744200" y="2514600"/>
             <a:ext cx="804672" cy="411480"/>
           </a:xfrm>
           <a:prstGeom prst="rect">
@@ -13056,7 +13366,7 @@
         </p:nvSpPr>
         <p:spPr>
           <a:xfrm>
-            <a:off x="5669280" y="3264408"/>
+            <a:off x="5669280" y="3026664"/>
             <a:ext cx="2286000" cy="411480"/>
           </a:xfrm>
           <a:prstGeom prst="rect">
@@ -13078,7 +13388,7 @@
                   <a:schemeClr val="tx1"/>
                 </a:solidFill>
               </a:rPr>
-              <a:t>High-intensity statin</a:t>
+              <a:t>SGLT2i (dapagliflozin)</a:t>
             </a:r>
             <a:endParaRPr lang="en-US" sz="1400" dirty="0"/>
           </a:p>
@@ -13092,7 +13402,7 @@
         </p:nvSpPr>
         <p:spPr>
           <a:xfrm>
-            <a:off x="8001000" y="3374136"/>
+            <a:off x="8001000" y="3136392"/>
             <a:ext cx="2651760" cy="201168"/>
           </a:xfrm>
           <a:prstGeom prst="roundRect">
@@ -13114,8 +13424,8 @@
         </p:nvSpPr>
         <p:spPr>
           <a:xfrm>
-            <a:off x="8001000" y="3374136"/>
-            <a:ext cx="1060704" cy="201168"/>
+            <a:off x="8001000" y="3136392"/>
+            <a:ext cx="681881" cy="201168"/>
           </a:xfrm>
           <a:prstGeom prst="roundRect">
             <a:avLst>
@@ -13138,8 +13448,102 @@
         </p:nvSpPr>
         <p:spPr>
           <a:xfrm>
-            <a:off x="8834410" y="3374136"/>
-            <a:ext cx="227294" cy="201168"/>
+            <a:off x="8618873" y="3136392"/>
+            <a:ext cx="128016" cy="201168"/>
+          </a:xfrm>
+          <a:prstGeom prst="roundRect">
+            <a:avLst>
+              <a:gd name="adj" fmla="val 71429"/>
+            </a:avLst>
+          </a:prstGeom>
+          <a:solidFill>
+            <a:schemeClr val="accent1"/>
+          </a:solidFill>
+          <a:ln/>
+        </p:spPr>
+      </p:sp>
+      <p:sp>
+        <p:nvSpPr>
+          <p:cNvPr id="22" name="Text 20"/>
+          <p:cNvSpPr txBox="1"/>
+          <p:nvPr/>
+        </p:nvSpPr>
+        <p:spPr>
+          <a:xfrm>
+            <a:off x="10744200" y="3026664"/>
+            <a:ext cx="804672" cy="411480"/>
+          </a:xfrm>
+          <a:prstGeom prst="rect">
+            <a:avLst/>
+          </a:prstGeom>
+          <a:noFill/>
+          <a:ln/>
+        </p:spPr>
+        <p:txBody>
+          <a:bodyPr wrap="square" lIns="0" tIns="0" rIns="0" bIns="0" rtlCol="0" anchor="ctr"/>
+          <a:lstStyle/>
+          <a:p>
+            <a:pPr algn="r" indent="0" marL="0">
+              <a:buNone/>
+            </a:pPr>
+            <a:r>
+              <a:rPr lang="en-US" sz="1400" b="1" dirty="0">
+                <a:solidFill>
+                  <a:schemeClr val="tx2"/>
+                </a:solidFill>
+              </a:rPr>
+              <a:t>18%</a:t>
+            </a:r>
+            <a:endParaRPr lang="en-US" sz="1400" dirty="0"/>
+          </a:p>
+        </p:txBody>
+      </p:sp>
+      <p:sp>
+        <p:nvSpPr>
+          <p:cNvPr id="23" name="Text 21"/>
+          <p:cNvSpPr txBox="1"/>
+          <p:nvPr/>
+        </p:nvSpPr>
+        <p:spPr>
+          <a:xfrm>
+            <a:off x="5669280" y="3538728"/>
+            <a:ext cx="2286000" cy="411480"/>
+          </a:xfrm>
+          <a:prstGeom prst="rect">
+            <a:avLst/>
+          </a:prstGeom>
+          <a:noFill/>
+          <a:ln/>
+        </p:spPr>
+        <p:txBody>
+          <a:bodyPr wrap="square" lIns="0" tIns="0" rIns="0" bIns="0" rtlCol="0" anchor="ctr"/>
+          <a:lstStyle/>
+          <a:p>
+            <a:pPr indent="0" marL="0">
+              <a:buNone/>
+            </a:pPr>
+            <a:r>
+              <a:rPr lang="en-US" sz="1400" dirty="0">
+                <a:solidFill>
+                  <a:schemeClr val="tx1"/>
+                </a:solidFill>
+              </a:rPr>
+              <a:t>High-intensity statin</a:t>
+            </a:r>
+            <a:endParaRPr lang="en-US" sz="1400" dirty="0"/>
+          </a:p>
+        </p:txBody>
+      </p:sp>
+      <p:sp>
+        <p:nvSpPr>
+          <p:cNvPr id="24" name="Track 3"/>
+          <p:cNvSpPr/>
+          <p:nvPr/>
+        </p:nvSpPr>
+        <p:spPr>
+          <a:xfrm>
+            <a:off x="8001000" y="3648456"/>
+            <a:ext cx="2651760" cy="201168"/>
           </a:xfrm>
           <a:prstGeom prst="roundRect">
             <a:avLst>
@@ -13147,100 +13551,6 @@
             </a:avLst>
           </a:prstGeom>
           <a:solidFill>
-            <a:schemeClr val="accent1"/>
-          </a:solidFill>
-          <a:ln/>
-        </p:spPr>
-      </p:sp>
-      <p:sp>
-        <p:nvSpPr>
-          <p:cNvPr id="22" name="Text 20"/>
-          <p:cNvSpPr txBox="1"/>
-          <p:nvPr/>
-        </p:nvSpPr>
-        <p:spPr>
-          <a:xfrm>
-            <a:off x="10744200" y="3264408"/>
-            <a:ext cx="804672" cy="411480"/>
-          </a:xfrm>
-          <a:prstGeom prst="rect">
-            <a:avLst/>
-          </a:prstGeom>
-          <a:noFill/>
-          <a:ln/>
-        </p:spPr>
-        <p:txBody>
-          <a:bodyPr wrap="square" lIns="0" tIns="0" rIns="0" bIns="0" rtlCol="0" anchor="ctr"/>
-          <a:lstStyle/>
-          <a:p>
-            <a:pPr algn="r" indent="0" marL="0">
-              <a:buNone/>
-            </a:pPr>
-            <a:r>
-              <a:rPr lang="en-US" sz="1400" b="1" dirty="0">
-                <a:solidFill>
-                  <a:schemeClr val="tx2"/>
-                </a:solidFill>
-              </a:rPr>
-              <a:t>22–28%</a:t>
-            </a:r>
-            <a:endParaRPr lang="en-US" sz="1400" dirty="0"/>
-          </a:p>
-        </p:txBody>
-      </p:sp>
-      <p:sp>
-        <p:nvSpPr>
-          <p:cNvPr id="23" name="Text 21"/>
-          <p:cNvSpPr txBox="1"/>
-          <p:nvPr/>
-        </p:nvSpPr>
-        <p:spPr>
-          <a:xfrm>
-            <a:off x="5669280" y="3922776"/>
-            <a:ext cx="2286000" cy="411480"/>
-          </a:xfrm>
-          <a:prstGeom prst="rect">
-            <a:avLst/>
-          </a:prstGeom>
-          <a:noFill/>
-          <a:ln/>
-        </p:spPr>
-        <p:txBody>
-          <a:bodyPr wrap="square" lIns="0" tIns="0" rIns="0" bIns="0" rtlCol="0" anchor="ctr"/>
-          <a:lstStyle/>
-          <a:p>
-            <a:pPr indent="0" marL="0">
-              <a:buNone/>
-            </a:pPr>
-            <a:r>
-              <a:rPr lang="en-US" sz="1400" dirty="0">
-                <a:solidFill>
-                  <a:schemeClr val="tx1"/>
-                </a:solidFill>
-              </a:rPr>
-              <a:t>Antihypertensives</a:t>
-            </a:r>
-            <a:endParaRPr lang="en-US" sz="1400" dirty="0"/>
-          </a:p>
-        </p:txBody>
-      </p:sp>
-      <p:sp>
-        <p:nvSpPr>
-          <p:cNvPr id="24" name="Track 3"/>
-          <p:cNvSpPr/>
-          <p:nvPr/>
-        </p:nvSpPr>
-        <p:spPr>
-          <a:xfrm>
-            <a:off x="8001000" y="4032504"/>
-            <a:ext cx="2651760" cy="201168"/>
-          </a:xfrm>
-          <a:prstGeom prst="roundRect">
-            <a:avLst>
-              <a:gd name="adj" fmla="val 45455"/>
-            </a:avLst>
-          </a:prstGeom>
-          <a:solidFill>
             <a:schemeClr val="bg2"/>
           </a:solidFill>
           <a:ln/>
@@ -13254,8 +13564,8 @@
         </p:nvSpPr>
         <p:spPr>
           <a:xfrm>
-            <a:off x="8001000" y="4032504"/>
-            <a:ext cx="1287998" cy="201168"/>
+            <a:off x="8001000" y="3648456"/>
+            <a:ext cx="1060704" cy="201168"/>
           </a:xfrm>
           <a:prstGeom prst="roundRect">
             <a:avLst>
@@ -13278,7 +13588,7 @@
         </p:nvSpPr>
         <p:spPr>
           <a:xfrm>
-            <a:off x="9061704" y="4032504"/>
+            <a:off x="8834410" y="3648456"/>
             <a:ext cx="227294" cy="201168"/>
           </a:xfrm>
           <a:prstGeom prst="roundRect">
@@ -13300,7 +13610,7 @@
         </p:nvSpPr>
         <p:spPr>
           <a:xfrm>
-            <a:off x="10744200" y="3922776"/>
+            <a:off x="10744200" y="3538728"/>
             <a:ext cx="804672" cy="411480"/>
           </a:xfrm>
           <a:prstGeom prst="rect">
@@ -13322,7 +13632,7 @@
                   <a:schemeClr val="tx2"/>
                 </a:solidFill>
               </a:rPr>
-              <a:t>28–34%</a:t>
+              <a:t>22–28%</a:t>
             </a:r>
             <a:endParaRPr lang="en-US" sz="1400" dirty="0"/>
           </a:p>
@@ -13336,7 +13646,7 @@
         </p:nvSpPr>
         <p:spPr>
           <a:xfrm>
-            <a:off x="5669280" y="4581144"/>
+            <a:off x="5669280" y="4050792"/>
             <a:ext cx="2286000" cy="411480"/>
           </a:xfrm>
           <a:prstGeom prst="rect">
@@ -13358,7 +13668,7 @@
                   <a:schemeClr val="tx1"/>
                 </a:solidFill>
               </a:rPr>
-              <a:t>Smoking cessation</a:t>
+              <a:t>Antihypertensives</a:t>
             </a:r>
             <a:endParaRPr lang="en-US" sz="1400" dirty="0"/>
           </a:p>
@@ -13372,7 +13682,7 @@
         </p:nvSpPr>
         <p:spPr>
           <a:xfrm>
-            <a:off x="8001000" y="4690872"/>
+            <a:off x="8001000" y="4160520"/>
             <a:ext cx="2651760" cy="201168"/>
           </a:xfrm>
           <a:prstGeom prst="roundRect">
@@ -13394,8 +13704,8 @@
         </p:nvSpPr>
         <p:spPr>
           <a:xfrm>
-            <a:off x="8001000" y="4690872"/>
-            <a:ext cx="1894114" cy="201168"/>
+            <a:off x="8001000" y="4160520"/>
+            <a:ext cx="1287998" cy="201168"/>
           </a:xfrm>
           <a:prstGeom prst="roundRect">
             <a:avLst>
@@ -13418,8 +13728,8 @@
         </p:nvSpPr>
         <p:spPr>
           <a:xfrm>
-            <a:off x="9516291" y="4690872"/>
-            <a:ext cx="378823" cy="201168"/>
+            <a:off x="9061704" y="4160520"/>
+            <a:ext cx="227294" cy="201168"/>
           </a:xfrm>
           <a:prstGeom prst="roundRect">
             <a:avLst>
@@ -13440,7 +13750,7 @@
         </p:nvSpPr>
         <p:spPr>
           <a:xfrm>
-            <a:off x="10744200" y="4581144"/>
+            <a:off x="10744200" y="4050792"/>
             <a:ext cx="804672" cy="411480"/>
           </a:xfrm>
           <a:prstGeom prst="rect">
@@ -13462,7 +13772,7 @@
                   <a:schemeClr val="tx2"/>
                 </a:solidFill>
               </a:rPr>
-              <a:t>40–50%</a:t>
+              <a:t>28–34%</a:t>
             </a:r>
             <a:endParaRPr lang="en-US" sz="1400" dirty="0"/>
           </a:p>
@@ -13476,7 +13786,7 @@
         </p:nvSpPr>
         <p:spPr>
           <a:xfrm>
-            <a:off x="5669280" y="5239512"/>
+            <a:off x="5669280" y="4562856"/>
             <a:ext cx="2286000" cy="411480"/>
           </a:xfrm>
           <a:prstGeom prst="rect">
@@ -13493,12 +13803,12 @@
               <a:buNone/>
             </a:pPr>
             <a:r>
-              <a:rPr lang="en-US" sz="1400" b="1" dirty="0">
+              <a:rPr lang="en-US" sz="1400" dirty="0">
                 <a:solidFill>
                   <a:schemeClr val="tx1"/>
                 </a:solidFill>
               </a:rPr>
-              <a:t>Combined protocol</a:t>
+              <a:t>Smoking cessation</a:t>
             </a:r>
             <a:endParaRPr lang="en-US" sz="1400" dirty="0"/>
           </a:p>
@@ -13512,7 +13822,7 @@
         </p:nvSpPr>
         <p:spPr>
           <a:xfrm>
-            <a:off x="8001000" y="5349240"/>
+            <a:off x="8001000" y="4672584"/>
             <a:ext cx="2651760" cy="201168"/>
           </a:xfrm>
           <a:prstGeom prst="roundRect">
@@ -13534,7 +13844,147 @@
         </p:nvSpPr>
         <p:spPr>
           <a:xfrm>
-            <a:off x="8001000" y="5349240"/>
+            <a:off x="8001000" y="4672584"/>
+            <a:ext cx="1894114" cy="201168"/>
+          </a:xfrm>
+          <a:prstGeom prst="roundRect">
+            <a:avLst>
+              <a:gd name="adj" fmla="val 45455"/>
+            </a:avLst>
+          </a:prstGeom>
+          <a:solidFill>
+            <a:schemeClr val="accent1">
+              <a:alpha val="22000"/>
+            </a:schemeClr>
+          </a:solidFill>
+          <a:ln/>
+        </p:spPr>
+      </p:sp>
+      <p:sp>
+        <p:nvSpPr>
+          <p:cNvPr id="36" name="Range 5"/>
+          <p:cNvSpPr/>
+          <p:nvPr/>
+        </p:nvSpPr>
+        <p:spPr>
+          <a:xfrm>
+            <a:off x="9516291" y="4672584"/>
+            <a:ext cx="378823" cy="201168"/>
+          </a:xfrm>
+          <a:prstGeom prst="roundRect">
+            <a:avLst>
+              <a:gd name="adj" fmla="val 45455"/>
+            </a:avLst>
+          </a:prstGeom>
+          <a:solidFill>
+            <a:schemeClr val="accent1"/>
+          </a:solidFill>
+          <a:ln/>
+        </p:spPr>
+      </p:sp>
+      <p:sp>
+        <p:nvSpPr>
+          <p:cNvPr id="37" name="Text 35"/>
+          <p:cNvSpPr txBox="1"/>
+          <p:nvPr/>
+        </p:nvSpPr>
+        <p:spPr>
+          <a:xfrm>
+            <a:off x="10744200" y="4562856"/>
+            <a:ext cx="804672" cy="411480"/>
+          </a:xfrm>
+          <a:prstGeom prst="rect">
+            <a:avLst/>
+          </a:prstGeom>
+          <a:noFill/>
+          <a:ln/>
+        </p:spPr>
+        <p:txBody>
+          <a:bodyPr wrap="square" lIns="0" tIns="0" rIns="0" bIns="0" rtlCol="0" anchor="ctr"/>
+          <a:lstStyle/>
+          <a:p>
+            <a:pPr algn="r" indent="0" marL="0">
+              <a:buNone/>
+            </a:pPr>
+            <a:r>
+              <a:rPr lang="en-US" sz="1400" b="1" dirty="0">
+                <a:solidFill>
+                  <a:schemeClr val="tx2"/>
+                </a:solidFill>
+              </a:rPr>
+              <a:t>40–50%</a:t>
+            </a:r>
+            <a:endParaRPr lang="en-US" sz="1400" dirty="0"/>
+          </a:p>
+        </p:txBody>
+      </p:sp>
+      <p:sp>
+        <p:nvSpPr>
+          <p:cNvPr id="38" name="Text 36"/>
+          <p:cNvSpPr txBox="1"/>
+          <p:nvPr/>
+        </p:nvSpPr>
+        <p:spPr>
+          <a:xfrm>
+            <a:off x="5669280" y="5074920"/>
+            <a:ext cx="2286000" cy="411480"/>
+          </a:xfrm>
+          <a:prstGeom prst="rect">
+            <a:avLst/>
+          </a:prstGeom>
+          <a:noFill/>
+          <a:ln/>
+        </p:spPr>
+        <p:txBody>
+          <a:bodyPr wrap="square" lIns="0" tIns="0" rIns="0" bIns="0" rtlCol="0" anchor="ctr"/>
+          <a:lstStyle/>
+          <a:p>
+            <a:pPr indent="0" marL="0">
+              <a:buNone/>
+            </a:pPr>
+            <a:r>
+              <a:rPr lang="en-US" sz="1400" b="1" dirty="0">
+                <a:solidFill>
+                  <a:schemeClr val="tx1"/>
+                </a:solidFill>
+              </a:rPr>
+              <a:t>Combined protocol</a:t>
+            </a:r>
+            <a:endParaRPr lang="en-US" sz="1400" dirty="0"/>
+          </a:p>
+        </p:txBody>
+      </p:sp>
+      <p:sp>
+        <p:nvSpPr>
+          <p:cNvPr id="39" name="Track 6"/>
+          <p:cNvSpPr/>
+          <p:nvPr/>
+        </p:nvSpPr>
+        <p:spPr>
+          <a:xfrm>
+            <a:off x="8001000" y="5184648"/>
+            <a:ext cx="2651760" cy="201168"/>
+          </a:xfrm>
+          <a:prstGeom prst="roundRect">
+            <a:avLst>
+              <a:gd name="adj" fmla="val 45455"/>
+            </a:avLst>
+          </a:prstGeom>
+          <a:solidFill>
+            <a:schemeClr val="bg2"/>
+          </a:solidFill>
+          <a:ln/>
+        </p:spPr>
+      </p:sp>
+      <p:sp>
+        <p:nvSpPr>
+          <p:cNvPr id="40" name="Up to 6"/>
+          <p:cNvSpPr/>
+          <p:nvPr/>
+        </p:nvSpPr>
+        <p:spPr>
+          <a:xfrm>
+            <a:off x="8001000" y="5184648"/>
             <a:ext cx="2575995" cy="201168"/>
           </a:xfrm>
           <a:prstGeom prst="roundRect">
@@ -13552,13 +14002,13 @@
       </p:sp>
       <p:sp>
         <p:nvSpPr>
-          <p:cNvPr id="36" name="Range 5"/>
+          <p:cNvPr id="41" name="Range 6"/>
           <p:cNvSpPr/>
           <p:nvPr/>
         </p:nvSpPr>
         <p:spPr>
           <a:xfrm>
-            <a:off x="10084526" y="5349240"/>
+            <a:off x="10084526" y="5184648"/>
             <a:ext cx="492470" cy="201168"/>
           </a:xfrm>
           <a:prstGeom prst="roundRect">
@@ -13574,13 +14024,13 @@
       </p:sp>
       <p:sp>
         <p:nvSpPr>
-          <p:cNvPr id="37" name="Text 35"/>
-          <p:cNvSpPr txBox="1"/>
-          <p:nvPr/>
-        </p:nvSpPr>
-        <p:spPr>
-          <a:xfrm>
-            <a:off x="10744200" y="5239512"/>
+          <p:cNvPr id="42" name="Text 40"/>
+          <p:cNvSpPr txBox="1"/>
+          <p:nvPr/>
+        </p:nvSpPr>
+        <p:spPr>
+          <a:xfrm>
+            <a:off x="10744200" y="5074920"/>
             <a:ext cx="804672" cy="411480"/>
           </a:xfrm>
           <a:prstGeom prst="rect">
@@ -13610,14 +14060,14 @@
       </p:sp>
       <p:sp>
         <p:nvSpPr>
-          <p:cNvPr id="38" name="Text 36"/>
-          <p:cNvSpPr txBox="1"/>
-          <p:nvPr/>
-        </p:nvSpPr>
-        <p:spPr>
-          <a:xfrm>
-            <a:off x="5669280" y="5943600"/>
-            <a:ext cx="5879592" cy="320040"/>
+          <p:cNvPr id="43" name="Text 41"/>
+          <p:cNvSpPr txBox="1"/>
+          <p:nvPr/>
+        </p:nvSpPr>
+        <p:spPr>
+          <a:xfrm>
+            <a:off x="5669280" y="5623560"/>
+            <a:ext cx="5879592" cy="685800"/>
           </a:xfrm>
           <a:prstGeom prst="rect">
             <a:avLst/>
@@ -13638,7 +14088,7 @@
                   <a:schemeClr val="accent6"/>
                 </a:solidFill>
               </a:rPr>
-              <a:t>Educational projections assuming 5–10 years of adherence. Smoking cessation benefit measured over 5 years.</a:t>
+              <a:t>Dual horizon: 24-hour hemodynamic twin response (resting HR, SBP, +RMSSD vagal recovery) and 10-year recalibrated ASCVD risk, with EHR-aware medication optimization. Dapagliflozin 10 mg shown. Educational projections assuming 5–10 years of adherence.</a:t>
             </a:r>
             <a:endParaRPr lang="en-US" sz="1200" dirty="0"/>
           </a:p>

</xml_diff>